<commit_message>
Update SOP and PPT for combined health-all report and JSON parsed outputs
- PARSER_SOP.md: update §11 (health-all → single combined HTML), §14 (single-device
  adds Parsed JSON section; health-all describes matrix + per-device accordions),
  §15 end-to-end workflow comment updated
- build_ppt.py: slide_html_reports rebuilt — single-device layout adds Parsed JSON row;
  new combined health-all section (check×device matrix + accordions); delta-all index kept;
  slide_report_overview health-all output updated; slide_collector workflow updated
- PARSER_SOP.pptx: regenerated (24 slides)

https://claude.ai/code/session_01Ljh3YjRKh7T8VazPj7qhgB
</commit_message>
<xml_diff>
--- a/network_cli_parser/PARSER_SOP.pptx
+++ b/network_cli_parser/PARSER_SOP.pptx
@@ -3799,7 +3799,7 @@
                         <a:rPr sz="1200">
                           <a:latin typeface="Calibri"/>
                         </a:rPr>
-                        <a:t>HTML + index.html</a:t>
+                        <a:t>Single combined HTML report</a:t>
                       </a:r>
                     </a:p>
                   </a:txBody>
@@ -13990,7 +13990,7 @@
                 </a:solidFill>
                 <a:latin typeface="Calibri"/>
               </a:rPr>
-              <a:t>All CSS and JS embedded; single .html file per device + index.html for multi-device</a:t>
+              <a:t>All CSS and JS embedded; single .html file per report type</a:t>
             </a:r>
           </a:p>
         </p:txBody>
@@ -14025,7 +14025,7 @@
                 </a:solidFill>
                 <a:latin typeface="Calibri"/>
               </a:rPr>
-              <a:t>Health report layout</a:t>
+              <a:t>Single-device health report layout</a:t>
             </a:r>
           </a:p>
         </p:txBody>
@@ -14040,7 +14040,7 @@
         </p:nvGraphicFramePr>
         <p:xfrm>
           <a:off x="365760" y="1417320"/>
-          <a:ext cx="5394960" cy="2084832"/>
+          <a:ext cx="5394960" cy="2432304"/>
         </p:xfrm>
         <a:graphic>
           <a:graphicData uri="http://schemas.openxmlformats.org/drawingml/2006/table">
@@ -14310,6 +14310,48 @@
                   </a:tcPr>
                 </a:tc>
               </a:tr>
+              <a:tr h="347472">
+                <a:tc>
+                  <a:txBody>
+                    <a:bodyPr/>
+                    <a:lstStyle/>
+                    <a:p>
+                      <a:pPr algn="l"/>
+                      <a:r>
+                        <a:rPr sz="1100">
+                          <a:latin typeface="Calibri"/>
+                        </a:rPr>
+                        <a:t>Parsed JSON outputs</a:t>
+                      </a:r>
+                    </a:p>
+                  </a:txBody>
+                  <a:tcPr>
+                    <a:solidFill>
+                      <a:srgbClr val="DBE9F7"/>
+                    </a:solidFill>
+                  </a:tcPr>
+                </a:tc>
+                <a:tc>
+                  <a:txBody>
+                    <a:bodyPr/>
+                    <a:lstStyle/>
+                    <a:p>
+                      <a:pPr algn="l"/>
+                      <a:r>
+                        <a:rPr sz="1100">
+                          <a:latin typeface="Calibri"/>
+                        </a:rPr>
+                        <a:t>Structured parsed data per command; separate Expand All</a:t>
+                      </a:r>
+                    </a:p>
+                  </a:txBody>
+                  <a:tcPr>
+                    <a:solidFill>
+                      <a:srgbClr val="DBE9F7"/>
+                    </a:solidFill>
+                  </a:tcPr>
+                </a:tc>
+              </a:tr>
             </a:tbl>
           </a:graphicData>
         </a:graphic>
@@ -14344,7 +14386,7 @@
                 </a:solidFill>
                 <a:latin typeface="Calibri"/>
               </a:rPr>
-              <a:t>Delta report layout</a:t>
+              <a:t>Combined health-all report  (health_report.html)</a:t>
             </a:r>
           </a:p>
         </p:txBody>
@@ -14359,7 +14401,410 @@
         </p:nvGraphicFramePr>
         <p:xfrm>
           <a:off x="6080760" y="1417320"/>
-          <a:ext cx="5760720" cy="2084832"/>
+          <a:ext cx="5760720" cy="2779776"/>
+        </p:xfrm>
+        <a:graphic>
+          <a:graphicData uri="http://schemas.openxmlformats.org/drawingml/2006/table">
+            <a:tbl>
+              <a:tblPr firstRow="1" bandRow="1">
+                <a:tableStyleId>{5C22544A-7EE6-4342-B048-85BDC9FD1C3A}</a:tableStyleId>
+              </a:tblPr>
+              <a:tblGrid>
+                <a:gridCol w="2194560"/>
+                <a:gridCol w="3566160"/>
+              </a:tblGrid>
+              <a:tr h="347472">
+                <a:tc>
+                  <a:txBody>
+                    <a:bodyPr/>
+                    <a:lstStyle/>
+                    <a:p>
+                      <a:pPr algn="l"/>
+                      <a:r>
+                        <a:rPr sz="1100" b="1">
+                          <a:solidFill>
+                            <a:srgbClr val="FFFFFF"/>
+                          </a:solidFill>
+                          <a:latin typeface="Calibri"/>
+                        </a:rPr>
+                        <a:t>Section</a:t>
+                      </a:r>
+                    </a:p>
+                  </a:txBody>
+                  <a:tcPr>
+                    <a:solidFill>
+                      <a:srgbClr val="1A355E"/>
+                    </a:solidFill>
+                  </a:tcPr>
+                </a:tc>
+                <a:tc>
+                  <a:txBody>
+                    <a:bodyPr/>
+                    <a:lstStyle/>
+                    <a:p>
+                      <a:pPr algn="l"/>
+                      <a:r>
+                        <a:rPr sz="1100" b="1">
+                          <a:solidFill>
+                            <a:srgbClr val="FFFFFF"/>
+                          </a:solidFill>
+                          <a:latin typeface="Calibri"/>
+                        </a:rPr>
+                        <a:t>Description</a:t>
+                      </a:r>
+                    </a:p>
+                  </a:txBody>
+                  <a:tcPr>
+                    <a:solidFill>
+                      <a:srgbClr val="1A355E"/>
+                    </a:solidFill>
+                  </a:tcPr>
+                </a:tc>
+              </a:tr>
+              <a:tr h="347472">
+                <a:tc>
+                  <a:txBody>
+                    <a:bodyPr/>
+                    <a:lstStyle/>
+                    <a:p>
+                      <a:pPr algn="l"/>
+                      <a:r>
+                        <a:rPr sz="1100">
+                          <a:latin typeface="Calibri"/>
+                        </a:rPr>
+                        <a:t>Summary cards</a:t>
+                      </a:r>
+                    </a:p>
+                  </a:txBody>
+                  <a:tcPr>
+                    <a:solidFill>
+                      <a:srgbClr val="FFFFFF"/>
+                    </a:solidFill>
+                  </a:tcPr>
+                </a:tc>
+                <a:tc>
+                  <a:txBody>
+                    <a:bodyPr/>
+                    <a:lstStyle/>
+                    <a:p>
+                      <a:pPr algn="l"/>
+                      <a:r>
+                        <a:rPr sz="1100">
+                          <a:latin typeface="Calibri"/>
+                        </a:rPr>
+                        <a:t>Devices / Total check evals / Passed / Failed / Errors</a:t>
+                      </a:r>
+                    </a:p>
+                  </a:txBody>
+                  <a:tcPr>
+                    <a:solidFill>
+                      <a:srgbClr val="FFFFFF"/>
+                    </a:solidFill>
+                  </a:tcPr>
+                </a:tc>
+              </a:tr>
+              <a:tr h="347472">
+                <a:tc>
+                  <a:txBody>
+                    <a:bodyPr/>
+                    <a:lstStyle/>
+                    <a:p>
+                      <a:pPr algn="l"/>
+                      <a:r>
+                        <a:rPr sz="1100">
+                          <a:latin typeface="Calibri"/>
+                        </a:rPr>
+                        <a:t>Check × device matrix</a:t>
+                      </a:r>
+                    </a:p>
+                  </a:txBody>
+                  <a:tcPr>
+                    <a:solidFill>
+                      <a:srgbClr val="DBE9F7"/>
+                    </a:solidFill>
+                  </a:tcPr>
+                </a:tc>
+                <a:tc>
+                  <a:txBody>
+                    <a:bodyPr/>
+                    <a:lstStyle/>
+                    <a:p>
+                      <a:pPr algn="l"/>
+                      <a:r>
+                        <a:rPr sz="1100">
+                          <a:latin typeface="Calibri"/>
+                        </a:rPr>
+                        <a:t>Row per check, column per device; PASS/FAIL/ERR cells colour-coded</a:t>
+                      </a:r>
+                    </a:p>
+                  </a:txBody>
+                  <a:tcPr>
+                    <a:solidFill>
+                      <a:srgbClr val="DBE9F7"/>
+                    </a:solidFill>
+                  </a:tcPr>
+                </a:tc>
+              </a:tr>
+              <a:tr h="347472">
+                <a:tc>
+                  <a:txBody>
+                    <a:bodyPr/>
+                    <a:lstStyle/>
+                    <a:p>
+                      <a:pPr algn="l"/>
+                      <a:r>
+                        <a:rPr sz="1100">
+                          <a:latin typeface="Calibri"/>
+                        </a:rPr>
+                        <a:t>Matrix cell links</a:t>
+                      </a:r>
+                    </a:p>
+                  </a:txBody>
+                  <a:tcPr>
+                    <a:solidFill>
+                      <a:srgbClr val="FFFFFF"/>
+                    </a:solidFill>
+                  </a:tcPr>
+                </a:tc>
+                <a:tc>
+                  <a:txBody>
+                    <a:bodyPr/>
+                    <a:lstStyle/>
+                    <a:p>
+                      <a:pPr algn="l"/>
+                      <a:r>
+                        <a:rPr sz="1100">
+                          <a:latin typeface="Calibri"/>
+                        </a:rPr>
+                        <a:t>Click any cell → scrolls to that device's accordion</a:t>
+                      </a:r>
+                    </a:p>
+                  </a:txBody>
+                  <a:tcPr>
+                    <a:solidFill>
+                      <a:srgbClr val="FFFFFF"/>
+                    </a:solidFill>
+                  </a:tcPr>
+                </a:tc>
+              </a:tr>
+              <a:tr h="347472">
+                <a:tc>
+                  <a:txBody>
+                    <a:bodyPr/>
+                    <a:lstStyle/>
+                    <a:p>
+                      <a:pPr algn="l"/>
+                      <a:r>
+                        <a:rPr sz="1100">
+                          <a:latin typeface="Calibri"/>
+                        </a:rPr>
+                        <a:t>Per-device accordions</a:t>
+                      </a:r>
+                    </a:p>
+                  </a:txBody>
+                  <a:tcPr>
+                    <a:solidFill>
+                      <a:srgbClr val="DBE9F7"/>
+                    </a:solidFill>
+                  </a:tcPr>
+                </a:tc>
+                <a:tc>
+                  <a:txBody>
+                    <a:bodyPr/>
+                    <a:lstStyle/>
+                    <a:p>
+                      <a:pPr algn="l"/>
+                      <a:r>
+                        <a:rPr sz="1100">
+                          <a:latin typeface="Calibri"/>
+                        </a:rPr>
+                        <a:t>Click device name → expands full detail section</a:t>
+                      </a:r>
+                    </a:p>
+                  </a:txBody>
+                  <a:tcPr>
+                    <a:solidFill>
+                      <a:srgbClr val="DBE9F7"/>
+                    </a:solidFill>
+                  </a:tcPr>
+                </a:tc>
+              </a:tr>
+              <a:tr h="347472">
+                <a:tc>
+                  <a:txBody>
+                    <a:bodyPr/>
+                    <a:lstStyle/>
+                    <a:p>
+                      <a:pPr algn="l"/>
+                      <a:r>
+                        <a:rPr sz="1100">
+                          <a:latin typeface="Calibri"/>
+                        </a:rPr>
+                        <a:t>Accordion: checks</a:t>
+                      </a:r>
+                    </a:p>
+                  </a:txBody>
+                  <a:tcPr>
+                    <a:solidFill>
+                      <a:srgbClr val="FFFFFF"/>
+                    </a:solidFill>
+                  </a:tcPr>
+                </a:tc>
+                <a:tc>
+                  <a:txBody>
+                    <a:bodyPr/>
+                    <a:lstStyle/>
+                    <a:p>
+                      <a:pPr algn="l"/>
+                      <a:r>
+                        <a:rPr sz="1100">
+                          <a:latin typeface="Calibri"/>
+                        </a:rPr>
+                        <a:t>Full check result list with pass/fail badges</a:t>
+                      </a:r>
+                    </a:p>
+                  </a:txBody>
+                  <a:tcPr>
+                    <a:solidFill>
+                      <a:srgbClr val="FFFFFF"/>
+                    </a:solidFill>
+                  </a:tcPr>
+                </a:tc>
+              </a:tr>
+              <a:tr h="347472">
+                <a:tc>
+                  <a:txBody>
+                    <a:bodyPr/>
+                    <a:lstStyle/>
+                    <a:p>
+                      <a:pPr algn="l"/>
+                      <a:r>
+                        <a:rPr sz="1100">
+                          <a:latin typeface="Calibri"/>
+                        </a:rPr>
+                        <a:t>Accordion: raw CLI</a:t>
+                      </a:r>
+                    </a:p>
+                  </a:txBody>
+                  <a:tcPr>
+                    <a:solidFill>
+                      <a:srgbClr val="DBE9F7"/>
+                    </a:solidFill>
+                  </a:tcPr>
+                </a:tc>
+                <a:tc>
+                  <a:txBody>
+                    <a:bodyPr/>
+                    <a:lstStyle/>
+                    <a:p>
+                      <a:pPr algn="l"/>
+                      <a:r>
+                        <a:rPr sz="1100">
+                          <a:latin typeface="Calibri"/>
+                        </a:rPr>
+                        <a:t>All command raw outputs; Expand All / Collapse All</a:t>
+                      </a:r>
+                    </a:p>
+                  </a:txBody>
+                  <a:tcPr>
+                    <a:solidFill>
+                      <a:srgbClr val="DBE9F7"/>
+                    </a:solidFill>
+                  </a:tcPr>
+                </a:tc>
+              </a:tr>
+              <a:tr h="347472">
+                <a:tc>
+                  <a:txBody>
+                    <a:bodyPr/>
+                    <a:lstStyle/>
+                    <a:p>
+                      <a:pPr algn="l"/>
+                      <a:r>
+                        <a:rPr sz="1100">
+                          <a:latin typeface="Calibri"/>
+                        </a:rPr>
+                        <a:t>Accordion: parsed JSON</a:t>
+                      </a:r>
+                    </a:p>
+                  </a:txBody>
+                  <a:tcPr>
+                    <a:solidFill>
+                      <a:srgbClr val="FFFFFF"/>
+                    </a:solidFill>
+                  </a:tcPr>
+                </a:tc>
+                <a:tc>
+                  <a:txBody>
+                    <a:bodyPr/>
+                    <a:lstStyle/>
+                    <a:p>
+                      <a:pPr algn="l"/>
+                      <a:r>
+                        <a:rPr sz="1100">
+                          <a:latin typeface="Calibri"/>
+                        </a:rPr>
+                        <a:t>Structured JSON per command; separate Expand All</a:t>
+                      </a:r>
+                    </a:p>
+                  </a:txBody>
+                  <a:tcPr>
+                    <a:solidFill>
+                      <a:srgbClr val="FFFFFF"/>
+                    </a:solidFill>
+                  </a:tcPr>
+                </a:tc>
+              </a:tr>
+            </a:tbl>
+          </a:graphicData>
+        </a:graphic>
+      </p:graphicFrame>
+      <p:sp>
+        <p:nvSpPr>
+          <p:cNvPr id="9" name="TextBox 8"/>
+          <p:cNvSpPr txBox="1"/>
+          <p:nvPr/>
+        </p:nvSpPr>
+        <p:spPr>
+          <a:xfrm>
+            <a:off x="365760" y="4297680"/>
+            <a:ext cx="5394960" cy="274320"/>
+          </a:xfrm>
+          <a:prstGeom prst="rect">
+            <a:avLst/>
+          </a:prstGeom>
+          <a:noFill/>
+        </p:spPr>
+        <p:txBody>
+          <a:bodyPr wrap="square">
+            <a:spAutoFit/>
+          </a:bodyPr>
+          <a:lstStyle/>
+          <a:p>
+            <a:pPr algn="l"/>
+            <a:r>
+              <a:rPr sz="1300" b="1" i="0">
+                <a:solidFill>
+                  <a:srgbClr val="1A355E"/>
+                </a:solidFill>
+                <a:latin typeface="Calibri"/>
+              </a:rPr>
+              <a:t>Delta report layout</a:t>
+            </a:r>
+          </a:p>
+        </p:txBody>
+      </p:sp>
+      <p:graphicFrame>
+        <p:nvGraphicFramePr>
+          <p:cNvPr id="10" name="Table 9"/>
+          <p:cNvGraphicFramePr>
+            <a:graphicFrameLocks noGrp="1"/>
+          </p:cNvGraphicFramePr>
+          <p:nvPr/>
+        </p:nvGraphicFramePr>
+        <p:xfrm>
+          <a:off x="365760" y="4617720"/>
+          <a:ext cx="5394960" cy="2084832"/>
         </p:xfrm>
         <a:graphic>
           <a:graphicData uri="http://schemas.openxmlformats.org/drawingml/2006/table">
@@ -14369,7 +14814,7 @@
               </a:tblPr>
               <a:tblGrid>
                 <a:gridCol w="1920240"/>
-                <a:gridCol w="3840480"/>
+                <a:gridCol w="3474720"/>
               </a:tblGrid>
               <a:tr h="347472">
                 <a:tc>
@@ -14635,14 +15080,14 @@
       </p:graphicFrame>
       <p:sp>
         <p:nvSpPr>
-          <p:cNvPr id="9" name="TextBox 8"/>
+          <p:cNvPr id="11" name="TextBox 10"/>
           <p:cNvSpPr txBox="1"/>
           <p:nvPr/>
         </p:nvSpPr>
         <p:spPr>
           <a:xfrm>
-            <a:off x="365760" y="4160520"/>
-            <a:ext cx="11430000" cy="274320"/>
+            <a:off x="6080760" y="4297680"/>
+            <a:ext cx="5760720" cy="274320"/>
           </a:xfrm>
           <a:prstGeom prst="rect">
             <a:avLst/>
@@ -14663,22 +15108,22 @@
                 </a:solidFill>
                 <a:latin typeface="Calibri"/>
               </a:rPr>
-              <a:t>Index pages (health-all and delta-all)</a:t>
+              <a:t>delta-all index page</a:t>
             </a:r>
           </a:p>
         </p:txBody>
       </p:sp>
       <p:graphicFrame>
         <p:nvGraphicFramePr>
-          <p:cNvPr id="10" name="Table 9"/>
+          <p:cNvPr id="12" name="Table 11"/>
           <p:cNvGraphicFramePr>
             <a:graphicFrameLocks noGrp="1"/>
           </p:cNvGraphicFramePr>
           <p:nvPr/>
         </p:nvGraphicFramePr>
         <p:xfrm>
-          <a:off x="365760" y="4480560"/>
-          <a:ext cx="11430000" cy="1042416"/>
+          <a:off x="6080760" y="4617720"/>
+          <a:ext cx="5760720" cy="1737360"/>
         </p:xfrm>
         <a:graphic>
           <a:graphicData uri="http://schemas.openxmlformats.org/drawingml/2006/table">
@@ -14687,8 +15132,7 @@
                 <a:tableStyleId>{5C22544A-7EE6-4342-B048-85BDC9FD1C3A}</a:tableStyleId>
               </a:tblPr>
               <a:tblGrid>
-                <a:gridCol w="2011680"/>
-                <a:gridCol w="6675120"/>
+                <a:gridCol w="3017520"/>
                 <a:gridCol w="2743200"/>
               </a:tblGrid>
               <a:tr h="347472">
@@ -14705,7 +15149,7 @@
                           </a:solidFill>
                           <a:latin typeface="Calibri"/>
                         </a:rPr>
-                        <a:t>Index page</a:t>
+                        <a:t>Column</a:t>
                       </a:r>
                     </a:p>
                   </a:txBody>
@@ -14728,30 +15172,7 @@
                           </a:solidFill>
                           <a:latin typeface="Calibri"/>
                         </a:rPr>
-                        <a:t>Columns</a:t>
-                      </a:r>
-                    </a:p>
-                  </a:txBody>
-                  <a:tcPr>
-                    <a:solidFill>
-                      <a:srgbClr val="1A355E"/>
-                    </a:solidFill>
-                  </a:tcPr>
-                </a:tc>
-                <a:tc>
-                  <a:txBody>
-                    <a:bodyPr/>
-                    <a:lstStyle/>
-                    <a:p>
-                      <a:pPr algn="l"/>
-                      <a:r>
-                        <a:rPr sz="1100" b="1">
-                          <a:solidFill>
-                            <a:srgbClr val="FFFFFF"/>
-                          </a:solidFill>
-                          <a:latin typeface="Calibri"/>
-                        </a:rPr>
-                        <a:t>Row color</a:t>
+                        <a:t>Notes</a:t>
                       </a:r>
                     </a:p>
                   </a:txBody>
@@ -14773,7 +15194,7 @@
                         <a:rPr sz="1100">
                           <a:latin typeface="Calibri"/>
                         </a:rPr>
-                        <a:t>health-all index</a:t>
+                        <a:t>Hostname / Status</a:t>
                       </a:r>
                     </a:p>
                   </a:txBody>
@@ -14793,27 +15214,7 @@
                         <a:rPr sz="1100">
                           <a:latin typeface="Calibri"/>
                         </a:rPr>
-                        <a:t>Hostname / Timestamp / Total / Passed / Failed / Errors / Report</a:t>
-                      </a:r>
-                    </a:p>
-                  </a:txBody>
-                  <a:tcPr>
-                    <a:solidFill>
-                      <a:srgbClr val="FFFFFF"/>
-                    </a:solidFill>
-                  </a:tcPr>
-                </a:tc>
-                <a:tc>
-                  <a:txBody>
-                    <a:bodyPr/>
-                    <a:lstStyle/>
-                    <a:p>
-                      <a:pPr algn="l"/>
-                      <a:r>
-                        <a:rPr sz="1100">
-                          <a:latin typeface="Calibri"/>
-                        </a:rPr>
-                        <a:t>Muted if all-pass; red if any failure</a:t>
+                        <a:t>matched or UNMATCHED</a:t>
                       </a:r>
                     </a:p>
                   </a:txBody>
@@ -14835,7 +15236,7 @@
                         <a:rPr sz="1100">
                           <a:latin typeface="Calibri"/>
                         </a:rPr>
-                        <a:t>delta-all index</a:t>
+                        <a:t>Added / Removed / Changed / Unchanged</a:t>
                       </a:r>
                     </a:p>
                   </a:txBody>
@@ -14855,7 +15256,71 @@
                         <a:rPr sz="1100">
                           <a:latin typeface="Calibri"/>
                         </a:rPr>
-                        <a:t>Hostname / Status / Added / Removed / Changed / Unchanged / Report</a:t>
+                        <a:t>counts from delta summary</a:t>
+                      </a:r>
+                    </a:p>
+                  </a:txBody>
+                  <a:tcPr>
+                    <a:solidFill>
+                      <a:srgbClr val="DBE9F7"/>
+                    </a:solidFill>
+                  </a:tcPr>
+                </a:tc>
+              </a:tr>
+              <a:tr h="347472">
+                <a:tc>
+                  <a:txBody>
+                    <a:bodyPr/>
+                    <a:lstStyle/>
+                    <a:p>
+                      <a:pPr algn="l"/>
+                      <a:r>
+                        <a:rPr sz="1100">
+                          <a:latin typeface="Calibri"/>
+                        </a:rPr>
+                        <a:t>Report link</a:t>
+                      </a:r>
+                    </a:p>
+                  </a:txBody>
+                  <a:tcPr>
+                    <a:solidFill>
+                      <a:srgbClr val="FFFFFF"/>
+                    </a:solidFill>
+                  </a:tcPr>
+                </a:tc>
+                <a:tc>
+                  <a:txBody>
+                    <a:bodyPr/>
+                    <a:lstStyle/>
+                    <a:p>
+                      <a:pPr algn="l"/>
+                      <a:r>
+                        <a:rPr sz="1100">
+                          <a:latin typeface="Calibri"/>
+                        </a:rPr>
+                        <a:t>Links to per-device delta HTML</a:t>
+                      </a:r>
+                    </a:p>
+                  </a:txBody>
+                  <a:tcPr>
+                    <a:solidFill>
+                      <a:srgbClr val="FFFFFF"/>
+                    </a:solidFill>
+                  </a:tcPr>
+                </a:tc>
+              </a:tr>
+              <a:tr h="347472">
+                <a:tc>
+                  <a:txBody>
+                    <a:bodyPr/>
+                    <a:lstStyle/>
+                    <a:p>
+                      <a:pPr algn="l"/>
+                      <a:r>
+                        <a:rPr sz="1100">
+                          <a:latin typeface="Calibri"/>
+                        </a:rPr>
+                        <a:t>Row style</a:t>
                       </a:r>
                     </a:p>
                   </a:txBody>
@@ -14875,7 +15340,7 @@
                         <a:rPr sz="1100">
                           <a:latin typeface="Calibri"/>
                         </a:rPr>
-                        <a:t>Muted if clean; faded if unmatched</a:t>
+                        <a:t>Muted if clean; faded grey if unmatched</a:t>
                       </a:r>
                     </a:p>
                   </a:txBody>
@@ -14892,13 +15357,13 @@
       </p:graphicFrame>
       <p:sp>
         <p:nvSpPr>
-          <p:cNvPr id="11" name="TextBox 10"/>
+          <p:cNvPr id="13" name="TextBox 12"/>
           <p:cNvSpPr txBox="1"/>
           <p:nvPr/>
         </p:nvSpPr>
         <p:spPr>
           <a:xfrm>
-            <a:off x="365760" y="6080760"/>
+            <a:off x="365760" y="6537960"/>
             <a:ext cx="11430000" cy="411480"/>
           </a:xfrm>
           <a:prstGeom prst="rect">
@@ -14920,7 +15385,7 @@
                 </a:solidFill>
                 <a:latin typeface="Calibri"/>
               </a:rPr>
-              <a:t>Devices appearing in only one directory (delta-all) are listed as UNMATCHED with no report link.</a:t>
+              <a:t>health-all produces ONE combined HTML (no per-device files, no index).  delta-all produces per-device HTMLs + index.html.</a:t>
             </a:r>
           </a:p>
         </p:txBody>
@@ -15848,7 +16313,40 @@
                 </a:solidFill>
                 <a:latin typeface="Courier New"/>
               </a:rPr>
+              <a:t># Produces reports/delta/{hostname}_delta.html  +  reports/delta/index.html</a:t>
+            </a:r>
+          </a:p>
+          <a:p>
+            <a:r>
+              <a:rPr sz="1050">
+                <a:solidFill>
+                  <a:srgbClr val="444444"/>
+                </a:solidFill>
+                <a:latin typeface="Courier New"/>
+              </a:rPr>
+              <a:t/>
+            </a:r>
+          </a:p>
+          <a:p>
+            <a:r>
+              <a:rPr sz="1050">
+                <a:solidFill>
+                  <a:srgbClr val="444444"/>
+                </a:solidFill>
+                <a:latin typeface="Courier New"/>
+              </a:rPr>
               <a:t>python report.py health-all --dir data/json/ --default-checks checks/base.yaml --output-dir reports/health/</a:t>
+            </a:r>
+          </a:p>
+          <a:p>
+            <a:r>
+              <a:rPr sz="1050">
+                <a:solidFill>
+                  <a:srgbClr val="444444"/>
+                </a:solidFill>
+                <a:latin typeface="Courier New"/>
+              </a:rPr>
+              <a:t># Produces single reports/health/health_report.html  (matrix + per-device accordions)</a:t>
             </a:r>
           </a:p>
         </p:txBody>

</xml_diff>

<commit_message>
Split HTML reports into two slides; add dedicated health-all slide (25 total)
- slide_html_reports: now covers single-device health layout + delta report + delta-all index
- slide_health_all_report (new): combined health_report.html structure — check×device matrix,
  per-device accordions, CLI invocation examples, key behaviours
- build() updated to call both slides in order

https://claude.ai/code/session_01Ljh3YjRKh7T8VazPj7qhgB
</commit_message>
<xml_diff>
--- a/network_cli_parser/PARSER_SOP.pptx
+++ b/network_cli_parser/PARSER_SOP.pptx
@@ -29,6 +29,7 @@
     <p:sldId id="277" r:id="rId28"/>
     <p:sldId id="278" r:id="rId29"/>
     <p:sldId id="279" r:id="rId30"/>
+    <p:sldId id="280" r:id="rId31"/>
   </p:sldIdLst>
   <p:sldSz cx="12188952" cy="6858000" type="screen4x3"/>
   <p:notesSz cx="6858000" cy="9144000"/>
@@ -13955,7 +13956,7 @@
                 </a:solidFill>
                 <a:latin typeface="Calibri"/>
               </a:rPr>
-              <a:t>HTML Reports — Self-Contained, No Internet Required</a:t>
+              <a:t>HTML Reports — Health &amp; Delta</a:t>
             </a:r>
           </a:p>
         </p:txBody>
@@ -13990,7 +13991,7 @@
                 </a:solidFill>
                 <a:latin typeface="Calibri"/>
               </a:rPr>
-              <a:t>All CSS and JS embedded; single .html file per report type</a:t>
+              <a:t>All CSS and JS embedded; fully self-contained .html files — no internet required</a:t>
             </a:r>
           </a:p>
         </p:txBody>
@@ -14279,7 +14280,7 @@
                         <a:rPr sz="1100">
                           <a:latin typeface="Calibri"/>
                         </a:rPr>
-                        <a:t>Raw outputs</a:t>
+                        <a:t>Raw CLI outputs</a:t>
                       </a:r>
                     </a:p>
                   </a:txBody>
@@ -14299,7 +14300,7 @@
                         <a:rPr sz="1100">
                           <a:latin typeface="Calibri"/>
                         </a:rPr>
-                        <a:t>Every command's raw CLI text; Expand All / Collapse All</a:t>
+                        <a:t>Every command's raw text; Expand All / Collapse All</a:t>
                       </a:r>
                     </a:p>
                   </a:txBody>
@@ -14341,7 +14342,7 @@
                         <a:rPr sz="1100">
                           <a:latin typeface="Calibri"/>
                         </a:rPr>
-                        <a:t>Structured parsed data per command; separate Expand All</a:t>
+                        <a:t>Structured parsed data per command; independent Expand All</a:t>
                       </a:r>
                     </a:p>
                   </a:txBody>
@@ -14386,7 +14387,7 @@
                 </a:solidFill>
                 <a:latin typeface="Calibri"/>
               </a:rPr>
-              <a:t>Combined health-all report  (health_report.html)</a:t>
+              <a:t>Delta report layout</a:t>
             </a:r>
           </a:p>
         </p:txBody>
@@ -14401,410 +14402,7 @@
         </p:nvGraphicFramePr>
         <p:xfrm>
           <a:off x="6080760" y="1417320"/>
-          <a:ext cx="5760720" cy="2779776"/>
-        </p:xfrm>
-        <a:graphic>
-          <a:graphicData uri="http://schemas.openxmlformats.org/drawingml/2006/table">
-            <a:tbl>
-              <a:tblPr firstRow="1" bandRow="1">
-                <a:tableStyleId>{5C22544A-7EE6-4342-B048-85BDC9FD1C3A}</a:tableStyleId>
-              </a:tblPr>
-              <a:tblGrid>
-                <a:gridCol w="2194560"/>
-                <a:gridCol w="3566160"/>
-              </a:tblGrid>
-              <a:tr h="347472">
-                <a:tc>
-                  <a:txBody>
-                    <a:bodyPr/>
-                    <a:lstStyle/>
-                    <a:p>
-                      <a:pPr algn="l"/>
-                      <a:r>
-                        <a:rPr sz="1100" b="1">
-                          <a:solidFill>
-                            <a:srgbClr val="FFFFFF"/>
-                          </a:solidFill>
-                          <a:latin typeface="Calibri"/>
-                        </a:rPr>
-                        <a:t>Section</a:t>
-                      </a:r>
-                    </a:p>
-                  </a:txBody>
-                  <a:tcPr>
-                    <a:solidFill>
-                      <a:srgbClr val="1A355E"/>
-                    </a:solidFill>
-                  </a:tcPr>
-                </a:tc>
-                <a:tc>
-                  <a:txBody>
-                    <a:bodyPr/>
-                    <a:lstStyle/>
-                    <a:p>
-                      <a:pPr algn="l"/>
-                      <a:r>
-                        <a:rPr sz="1100" b="1">
-                          <a:solidFill>
-                            <a:srgbClr val="FFFFFF"/>
-                          </a:solidFill>
-                          <a:latin typeface="Calibri"/>
-                        </a:rPr>
-                        <a:t>Description</a:t>
-                      </a:r>
-                    </a:p>
-                  </a:txBody>
-                  <a:tcPr>
-                    <a:solidFill>
-                      <a:srgbClr val="1A355E"/>
-                    </a:solidFill>
-                  </a:tcPr>
-                </a:tc>
-              </a:tr>
-              <a:tr h="347472">
-                <a:tc>
-                  <a:txBody>
-                    <a:bodyPr/>
-                    <a:lstStyle/>
-                    <a:p>
-                      <a:pPr algn="l"/>
-                      <a:r>
-                        <a:rPr sz="1100">
-                          <a:latin typeface="Calibri"/>
-                        </a:rPr>
-                        <a:t>Summary cards</a:t>
-                      </a:r>
-                    </a:p>
-                  </a:txBody>
-                  <a:tcPr>
-                    <a:solidFill>
-                      <a:srgbClr val="FFFFFF"/>
-                    </a:solidFill>
-                  </a:tcPr>
-                </a:tc>
-                <a:tc>
-                  <a:txBody>
-                    <a:bodyPr/>
-                    <a:lstStyle/>
-                    <a:p>
-                      <a:pPr algn="l"/>
-                      <a:r>
-                        <a:rPr sz="1100">
-                          <a:latin typeface="Calibri"/>
-                        </a:rPr>
-                        <a:t>Devices / Total check evals / Passed / Failed / Errors</a:t>
-                      </a:r>
-                    </a:p>
-                  </a:txBody>
-                  <a:tcPr>
-                    <a:solidFill>
-                      <a:srgbClr val="FFFFFF"/>
-                    </a:solidFill>
-                  </a:tcPr>
-                </a:tc>
-              </a:tr>
-              <a:tr h="347472">
-                <a:tc>
-                  <a:txBody>
-                    <a:bodyPr/>
-                    <a:lstStyle/>
-                    <a:p>
-                      <a:pPr algn="l"/>
-                      <a:r>
-                        <a:rPr sz="1100">
-                          <a:latin typeface="Calibri"/>
-                        </a:rPr>
-                        <a:t>Check × device matrix</a:t>
-                      </a:r>
-                    </a:p>
-                  </a:txBody>
-                  <a:tcPr>
-                    <a:solidFill>
-                      <a:srgbClr val="DBE9F7"/>
-                    </a:solidFill>
-                  </a:tcPr>
-                </a:tc>
-                <a:tc>
-                  <a:txBody>
-                    <a:bodyPr/>
-                    <a:lstStyle/>
-                    <a:p>
-                      <a:pPr algn="l"/>
-                      <a:r>
-                        <a:rPr sz="1100">
-                          <a:latin typeface="Calibri"/>
-                        </a:rPr>
-                        <a:t>Row per check, column per device; PASS/FAIL/ERR cells colour-coded</a:t>
-                      </a:r>
-                    </a:p>
-                  </a:txBody>
-                  <a:tcPr>
-                    <a:solidFill>
-                      <a:srgbClr val="DBE9F7"/>
-                    </a:solidFill>
-                  </a:tcPr>
-                </a:tc>
-              </a:tr>
-              <a:tr h="347472">
-                <a:tc>
-                  <a:txBody>
-                    <a:bodyPr/>
-                    <a:lstStyle/>
-                    <a:p>
-                      <a:pPr algn="l"/>
-                      <a:r>
-                        <a:rPr sz="1100">
-                          <a:latin typeface="Calibri"/>
-                        </a:rPr>
-                        <a:t>Matrix cell links</a:t>
-                      </a:r>
-                    </a:p>
-                  </a:txBody>
-                  <a:tcPr>
-                    <a:solidFill>
-                      <a:srgbClr val="FFFFFF"/>
-                    </a:solidFill>
-                  </a:tcPr>
-                </a:tc>
-                <a:tc>
-                  <a:txBody>
-                    <a:bodyPr/>
-                    <a:lstStyle/>
-                    <a:p>
-                      <a:pPr algn="l"/>
-                      <a:r>
-                        <a:rPr sz="1100">
-                          <a:latin typeface="Calibri"/>
-                        </a:rPr>
-                        <a:t>Click any cell → scrolls to that device's accordion</a:t>
-                      </a:r>
-                    </a:p>
-                  </a:txBody>
-                  <a:tcPr>
-                    <a:solidFill>
-                      <a:srgbClr val="FFFFFF"/>
-                    </a:solidFill>
-                  </a:tcPr>
-                </a:tc>
-              </a:tr>
-              <a:tr h="347472">
-                <a:tc>
-                  <a:txBody>
-                    <a:bodyPr/>
-                    <a:lstStyle/>
-                    <a:p>
-                      <a:pPr algn="l"/>
-                      <a:r>
-                        <a:rPr sz="1100">
-                          <a:latin typeface="Calibri"/>
-                        </a:rPr>
-                        <a:t>Per-device accordions</a:t>
-                      </a:r>
-                    </a:p>
-                  </a:txBody>
-                  <a:tcPr>
-                    <a:solidFill>
-                      <a:srgbClr val="DBE9F7"/>
-                    </a:solidFill>
-                  </a:tcPr>
-                </a:tc>
-                <a:tc>
-                  <a:txBody>
-                    <a:bodyPr/>
-                    <a:lstStyle/>
-                    <a:p>
-                      <a:pPr algn="l"/>
-                      <a:r>
-                        <a:rPr sz="1100">
-                          <a:latin typeface="Calibri"/>
-                        </a:rPr>
-                        <a:t>Click device name → expands full detail section</a:t>
-                      </a:r>
-                    </a:p>
-                  </a:txBody>
-                  <a:tcPr>
-                    <a:solidFill>
-                      <a:srgbClr val="DBE9F7"/>
-                    </a:solidFill>
-                  </a:tcPr>
-                </a:tc>
-              </a:tr>
-              <a:tr h="347472">
-                <a:tc>
-                  <a:txBody>
-                    <a:bodyPr/>
-                    <a:lstStyle/>
-                    <a:p>
-                      <a:pPr algn="l"/>
-                      <a:r>
-                        <a:rPr sz="1100">
-                          <a:latin typeface="Calibri"/>
-                        </a:rPr>
-                        <a:t>Accordion: checks</a:t>
-                      </a:r>
-                    </a:p>
-                  </a:txBody>
-                  <a:tcPr>
-                    <a:solidFill>
-                      <a:srgbClr val="FFFFFF"/>
-                    </a:solidFill>
-                  </a:tcPr>
-                </a:tc>
-                <a:tc>
-                  <a:txBody>
-                    <a:bodyPr/>
-                    <a:lstStyle/>
-                    <a:p>
-                      <a:pPr algn="l"/>
-                      <a:r>
-                        <a:rPr sz="1100">
-                          <a:latin typeface="Calibri"/>
-                        </a:rPr>
-                        <a:t>Full check result list with pass/fail badges</a:t>
-                      </a:r>
-                    </a:p>
-                  </a:txBody>
-                  <a:tcPr>
-                    <a:solidFill>
-                      <a:srgbClr val="FFFFFF"/>
-                    </a:solidFill>
-                  </a:tcPr>
-                </a:tc>
-              </a:tr>
-              <a:tr h="347472">
-                <a:tc>
-                  <a:txBody>
-                    <a:bodyPr/>
-                    <a:lstStyle/>
-                    <a:p>
-                      <a:pPr algn="l"/>
-                      <a:r>
-                        <a:rPr sz="1100">
-                          <a:latin typeface="Calibri"/>
-                        </a:rPr>
-                        <a:t>Accordion: raw CLI</a:t>
-                      </a:r>
-                    </a:p>
-                  </a:txBody>
-                  <a:tcPr>
-                    <a:solidFill>
-                      <a:srgbClr val="DBE9F7"/>
-                    </a:solidFill>
-                  </a:tcPr>
-                </a:tc>
-                <a:tc>
-                  <a:txBody>
-                    <a:bodyPr/>
-                    <a:lstStyle/>
-                    <a:p>
-                      <a:pPr algn="l"/>
-                      <a:r>
-                        <a:rPr sz="1100">
-                          <a:latin typeface="Calibri"/>
-                        </a:rPr>
-                        <a:t>All command raw outputs; Expand All / Collapse All</a:t>
-                      </a:r>
-                    </a:p>
-                  </a:txBody>
-                  <a:tcPr>
-                    <a:solidFill>
-                      <a:srgbClr val="DBE9F7"/>
-                    </a:solidFill>
-                  </a:tcPr>
-                </a:tc>
-              </a:tr>
-              <a:tr h="347472">
-                <a:tc>
-                  <a:txBody>
-                    <a:bodyPr/>
-                    <a:lstStyle/>
-                    <a:p>
-                      <a:pPr algn="l"/>
-                      <a:r>
-                        <a:rPr sz="1100">
-                          <a:latin typeface="Calibri"/>
-                        </a:rPr>
-                        <a:t>Accordion: parsed JSON</a:t>
-                      </a:r>
-                    </a:p>
-                  </a:txBody>
-                  <a:tcPr>
-                    <a:solidFill>
-                      <a:srgbClr val="FFFFFF"/>
-                    </a:solidFill>
-                  </a:tcPr>
-                </a:tc>
-                <a:tc>
-                  <a:txBody>
-                    <a:bodyPr/>
-                    <a:lstStyle/>
-                    <a:p>
-                      <a:pPr algn="l"/>
-                      <a:r>
-                        <a:rPr sz="1100">
-                          <a:latin typeface="Calibri"/>
-                        </a:rPr>
-                        <a:t>Structured JSON per command; separate Expand All</a:t>
-                      </a:r>
-                    </a:p>
-                  </a:txBody>
-                  <a:tcPr>
-                    <a:solidFill>
-                      <a:srgbClr val="FFFFFF"/>
-                    </a:solidFill>
-                  </a:tcPr>
-                </a:tc>
-              </a:tr>
-            </a:tbl>
-          </a:graphicData>
-        </a:graphic>
-      </p:graphicFrame>
-      <p:sp>
-        <p:nvSpPr>
-          <p:cNvPr id="9" name="TextBox 8"/>
-          <p:cNvSpPr txBox="1"/>
-          <p:nvPr/>
-        </p:nvSpPr>
-        <p:spPr>
-          <a:xfrm>
-            <a:off x="365760" y="4297680"/>
-            <a:ext cx="5394960" cy="274320"/>
-          </a:xfrm>
-          <a:prstGeom prst="rect">
-            <a:avLst/>
-          </a:prstGeom>
-          <a:noFill/>
-        </p:spPr>
-        <p:txBody>
-          <a:bodyPr wrap="square">
-            <a:spAutoFit/>
-          </a:bodyPr>
-          <a:lstStyle/>
-          <a:p>
-            <a:pPr algn="l"/>
-            <a:r>
-              <a:rPr sz="1300" b="1" i="0">
-                <a:solidFill>
-                  <a:srgbClr val="1A355E"/>
-                </a:solidFill>
-                <a:latin typeface="Calibri"/>
-              </a:rPr>
-              <a:t>Delta report layout</a:t>
-            </a:r>
-          </a:p>
-        </p:txBody>
-      </p:sp>
-      <p:graphicFrame>
-        <p:nvGraphicFramePr>
-          <p:cNvPr id="10" name="Table 9"/>
-          <p:cNvGraphicFramePr>
-            <a:graphicFrameLocks noGrp="1"/>
-          </p:cNvGraphicFramePr>
-          <p:nvPr/>
-        </p:nvGraphicFramePr>
-        <p:xfrm>
-          <a:off x="365760" y="4617720"/>
-          <a:ext cx="5394960" cy="2084832"/>
+          <a:ext cx="5760720" cy="2084832"/>
         </p:xfrm>
         <a:graphic>
           <a:graphicData uri="http://schemas.openxmlformats.org/drawingml/2006/table">
@@ -14814,7 +14412,7 @@
               </a:tblPr>
               <a:tblGrid>
                 <a:gridCol w="1920240"/>
-                <a:gridCol w="3474720"/>
+                <a:gridCol w="3840480"/>
               </a:tblGrid>
               <a:tr h="347472">
                 <a:tc>
@@ -15063,7 +14661,7 @@
                         <a:rPr sz="1100">
                           <a:latin typeface="Calibri"/>
                         </a:rPr>
-                        <a:t>Changed: before + after side by side</a:t>
+                        <a:t>Changed commands: before + after side by side</a:t>
                       </a:r>
                     </a:p>
                   </a:txBody>
@@ -15080,14 +14678,14 @@
       </p:graphicFrame>
       <p:sp>
         <p:nvSpPr>
-          <p:cNvPr id="11" name="TextBox 10"/>
+          <p:cNvPr id="9" name="TextBox 8"/>
           <p:cNvSpPr txBox="1"/>
           <p:nvPr/>
         </p:nvSpPr>
         <p:spPr>
           <a:xfrm>
-            <a:off x="6080760" y="4297680"/>
-            <a:ext cx="5760720" cy="274320"/>
+            <a:off x="365760" y="4251960"/>
+            <a:ext cx="11430000" cy="274320"/>
           </a:xfrm>
           <a:prstGeom prst="rect">
             <a:avLst/>
@@ -15115,15 +14713,15 @@
       </p:sp>
       <p:graphicFrame>
         <p:nvGraphicFramePr>
-          <p:cNvPr id="12" name="Table 11"/>
+          <p:cNvPr id="10" name="Table 9"/>
           <p:cNvGraphicFramePr>
             <a:graphicFrameLocks noGrp="1"/>
           </p:cNvGraphicFramePr>
           <p:nvPr/>
         </p:nvGraphicFramePr>
         <p:xfrm>
-          <a:off x="6080760" y="4617720"/>
-          <a:ext cx="5760720" cy="1737360"/>
+          <a:off x="365760" y="4572000"/>
+          <a:ext cx="11430000" cy="1389888"/>
         </p:xfrm>
         <a:graphic>
           <a:graphicData uri="http://schemas.openxmlformats.org/drawingml/2006/table">
@@ -15132,8 +14730,8 @@
                 <a:tableStyleId>{5C22544A-7EE6-4342-B048-85BDC9FD1C3A}</a:tableStyleId>
               </a:tblPr>
               <a:tblGrid>
-                <a:gridCol w="3017520"/>
-                <a:gridCol w="2743200"/>
+                <a:gridCol w="2560320"/>
+                <a:gridCol w="8869680"/>
               </a:tblGrid>
               <a:tr h="347472">
                 <a:tc>
@@ -15214,7 +14812,7 @@
                         <a:rPr sz="1100">
                           <a:latin typeface="Calibri"/>
                         </a:rPr>
-                        <a:t>matched or UNMATCHED</a:t>
+                        <a:t>matched → link to delta HTML;  unmatched → faded, no link</a:t>
                       </a:r>
                     </a:p>
                   </a:txBody>
@@ -15256,7 +14854,7 @@
                         <a:rPr sz="1100">
                           <a:latin typeface="Calibri"/>
                         </a:rPr>
-                        <a:t>counts from delta summary</a:t>
+                        <a:t>counts from compute_delta() summary</a:t>
                       </a:r>
                     </a:p>
                   </a:txBody>
@@ -15278,7 +14876,7 @@
                         <a:rPr sz="1100">
                           <a:latin typeface="Calibri"/>
                         </a:rPr>
-                        <a:t>Report link</a:t>
+                        <a:t>Row style</a:t>
                       </a:r>
                     </a:p>
                   </a:txBody>
@@ -15298,7 +14896,324 @@
                         <a:rPr sz="1100">
                           <a:latin typeface="Calibri"/>
                         </a:rPr>
-                        <a:t>Links to per-device delta HTML</a:t>
+                        <a:t>Muted green-tint if zero changes; faded grey if unmatched device</a:t>
+                      </a:r>
+                    </a:p>
+                  </a:txBody>
+                  <a:tcPr>
+                    <a:solidFill>
+                      <a:srgbClr val="FFFFFF"/>
+                    </a:solidFill>
+                  </a:tcPr>
+                </a:tc>
+              </a:tr>
+            </a:tbl>
+          </a:graphicData>
+        </a:graphic>
+      </p:graphicFrame>
+      <p:sp>
+        <p:nvSpPr>
+          <p:cNvPr id="11" name="TextBox 10"/>
+          <p:cNvSpPr txBox="1"/>
+          <p:nvPr/>
+        </p:nvSpPr>
+        <p:spPr>
+          <a:xfrm>
+            <a:off x="365760" y="5989320"/>
+            <a:ext cx="11430000" cy="411480"/>
+          </a:xfrm>
+          <a:prstGeom prst="rect">
+            <a:avLst/>
+          </a:prstGeom>
+          <a:noFill/>
+        </p:spPr>
+        <p:txBody>
+          <a:bodyPr wrap="square">
+            <a:spAutoFit/>
+          </a:bodyPr>
+          <a:lstStyle/>
+          <a:p>
+            <a:pPr algn="l"/>
+            <a:r>
+              <a:rPr sz="1200" b="0" i="1">
+                <a:solidFill>
+                  <a:srgbClr val="444444"/>
+                </a:solidFill>
+                <a:latin typeface="Calibri"/>
+              </a:rPr>
+              <a:t>Devices appearing in only one directory (delta-all) are listed as UNMATCHED with no report link.</a:t>
+            </a:r>
+          </a:p>
+        </p:txBody>
+      </p:sp>
+    </p:spTree>
+  </p:cSld>
+  <p:clrMapOvr>
+    <a:masterClrMapping/>
+  </p:clrMapOvr>
+</p:sld>
+</file>
+
+<file path=ppt/slides/slide23.xml><?xml version="1.0" encoding="utf-8"?>
+<p:sld xmlns:a="http://schemas.openxmlformats.org/drawingml/2006/main" xmlns:p="http://schemas.openxmlformats.org/presentationml/2006/main" xmlns:r="http://schemas.openxmlformats.org/officeDocument/2006/relationships">
+  <p:cSld>
+    <p:spTree>
+      <p:nvGrpSpPr>
+        <p:cNvPr id="1" name=""/>
+        <p:cNvGrpSpPr/>
+        <p:nvPr/>
+      </p:nvGrpSpPr>
+      <p:grpSpPr/>
+      <p:sp>
+        <p:nvSpPr>
+          <p:cNvPr id="2" name="Rectangle 1"/>
+          <p:cNvSpPr/>
+          <p:nvPr/>
+        </p:nvSpPr>
+        <p:spPr>
+          <a:xfrm>
+            <a:off x="0" y="0"/>
+            <a:ext cx="12188952" cy="1005840"/>
+          </a:xfrm>
+          <a:prstGeom prst="rect">
+            <a:avLst/>
+          </a:prstGeom>
+          <a:solidFill>
+            <a:srgbClr val="1A355E"/>
+          </a:solidFill>
+          <a:ln>
+            <a:noFill/>
+          </a:ln>
+        </p:spPr>
+        <p:style>
+          <a:lnRef idx="1">
+            <a:schemeClr val="accent1"/>
+          </a:lnRef>
+          <a:fillRef idx="3">
+            <a:schemeClr val="accent1"/>
+          </a:fillRef>
+          <a:effectRef idx="2">
+            <a:schemeClr val="accent1"/>
+          </a:effectRef>
+          <a:fontRef idx="minor">
+            <a:schemeClr val="lt1"/>
+          </a:fontRef>
+        </p:style>
+        <p:txBody>
+          <a:bodyPr rtlCol="0" anchor="ctr"/>
+          <a:lstStyle/>
+          <a:p>
+            <a:pPr algn="ctr"/>
+          </a:p>
+        </p:txBody>
+      </p:sp>
+      <p:sp>
+        <p:nvSpPr>
+          <p:cNvPr id="3" name="TextBox 2"/>
+          <p:cNvSpPr txBox="1"/>
+          <p:nvPr/>
+        </p:nvSpPr>
+        <p:spPr>
+          <a:xfrm>
+            <a:off x="320040" y="91440"/>
+            <a:ext cx="11430000" cy="594360"/>
+          </a:xfrm>
+          <a:prstGeom prst="rect">
+            <a:avLst/>
+          </a:prstGeom>
+          <a:noFill/>
+        </p:spPr>
+        <p:txBody>
+          <a:bodyPr wrap="square">
+            <a:spAutoFit/>
+          </a:bodyPr>
+          <a:lstStyle/>
+          <a:p>
+            <a:pPr algn="l"/>
+            <a:r>
+              <a:rPr sz="2400" b="1" i="0">
+                <a:solidFill>
+                  <a:srgbClr val="FFFFFF"/>
+                </a:solidFill>
+                <a:latin typeface="Calibri"/>
+              </a:rPr>
+              <a:t>Combined Health-All Report  (health_report.html)</a:t>
+            </a:r>
+          </a:p>
+        </p:txBody>
+      </p:sp>
+      <p:sp>
+        <p:nvSpPr>
+          <p:cNvPr id="4" name="TextBox 3"/>
+          <p:cNvSpPr txBox="1"/>
+          <p:nvPr/>
+        </p:nvSpPr>
+        <p:spPr>
+          <a:xfrm>
+            <a:off x="320040" y="658368"/>
+            <a:ext cx="11430000" cy="292608"/>
+          </a:xfrm>
+          <a:prstGeom prst="rect">
+            <a:avLst/>
+          </a:prstGeom>
+          <a:noFill/>
+        </p:spPr>
+        <p:txBody>
+          <a:bodyPr wrap="square">
+            <a:spAutoFit/>
+          </a:bodyPr>
+          <a:lstStyle/>
+          <a:p>
+            <a:pPr algn="l"/>
+            <a:r>
+              <a:rPr sz="1300" b="0" i="0">
+                <a:solidFill>
+                  <a:srgbClr val="CCDDF0"/>
+                </a:solidFill>
+                <a:latin typeface="Calibri"/>
+              </a:rPr>
+              <a:t>One file covers all devices — check × device matrix at the top, full detail per device below</a:t>
+            </a:r>
+          </a:p>
+        </p:txBody>
+      </p:sp>
+      <p:sp>
+        <p:nvSpPr>
+          <p:cNvPr id="5" name="TextBox 4"/>
+          <p:cNvSpPr txBox="1"/>
+          <p:nvPr/>
+        </p:nvSpPr>
+        <p:spPr>
+          <a:xfrm>
+            <a:off x="365760" y="1097280"/>
+            <a:ext cx="5394960" cy="274320"/>
+          </a:xfrm>
+          <a:prstGeom prst="rect">
+            <a:avLst/>
+          </a:prstGeom>
+          <a:noFill/>
+        </p:spPr>
+        <p:txBody>
+          <a:bodyPr wrap="square">
+            <a:spAutoFit/>
+          </a:bodyPr>
+          <a:lstStyle/>
+          <a:p>
+            <a:pPr algn="l"/>
+            <a:r>
+              <a:rPr sz="1300" b="1" i="0">
+                <a:solidFill>
+                  <a:srgbClr val="1A355E"/>
+                </a:solidFill>
+                <a:latin typeface="Calibri"/>
+              </a:rPr>
+              <a:t>Report structure</a:t>
+            </a:r>
+          </a:p>
+        </p:txBody>
+      </p:sp>
+      <p:graphicFrame>
+        <p:nvGraphicFramePr>
+          <p:cNvPr id="6" name="Table 5"/>
+          <p:cNvGraphicFramePr>
+            <a:graphicFrameLocks noGrp="1"/>
+          </p:cNvGraphicFramePr>
+          <p:nvPr/>
+        </p:nvGraphicFramePr>
+        <p:xfrm>
+          <a:off x="365760" y="1417320"/>
+          <a:ext cx="5394960" cy="3127248"/>
+        </p:xfrm>
+        <a:graphic>
+          <a:graphicData uri="http://schemas.openxmlformats.org/drawingml/2006/table">
+            <a:tbl>
+              <a:tblPr firstRow="1" bandRow="1">
+                <a:tableStyleId>{5C22544A-7EE6-4342-B048-85BDC9FD1C3A}</a:tableStyleId>
+              </a:tblPr>
+              <a:tblGrid>
+                <a:gridCol w="2194560"/>
+                <a:gridCol w="3200400"/>
+              </a:tblGrid>
+              <a:tr h="347472">
+                <a:tc>
+                  <a:txBody>
+                    <a:bodyPr/>
+                    <a:lstStyle/>
+                    <a:p>
+                      <a:pPr algn="l"/>
+                      <a:r>
+                        <a:rPr sz="1100" b="1">
+                          <a:solidFill>
+                            <a:srgbClr val="FFFFFF"/>
+                          </a:solidFill>
+                          <a:latin typeface="Calibri"/>
+                        </a:rPr>
+                        <a:t>Section</a:t>
+                      </a:r>
+                    </a:p>
+                  </a:txBody>
+                  <a:tcPr>
+                    <a:solidFill>
+                      <a:srgbClr val="1A355E"/>
+                    </a:solidFill>
+                  </a:tcPr>
+                </a:tc>
+                <a:tc>
+                  <a:txBody>
+                    <a:bodyPr/>
+                    <a:lstStyle/>
+                    <a:p>
+                      <a:pPr algn="l"/>
+                      <a:r>
+                        <a:rPr sz="1100" b="1">
+                          <a:solidFill>
+                            <a:srgbClr val="FFFFFF"/>
+                          </a:solidFill>
+                          <a:latin typeface="Calibri"/>
+                        </a:rPr>
+                        <a:t>Description</a:t>
+                      </a:r>
+                    </a:p>
+                  </a:txBody>
+                  <a:tcPr>
+                    <a:solidFill>
+                      <a:srgbClr val="1A355E"/>
+                    </a:solidFill>
+                  </a:tcPr>
+                </a:tc>
+              </a:tr>
+              <a:tr h="347472">
+                <a:tc>
+                  <a:txBody>
+                    <a:bodyPr/>
+                    <a:lstStyle/>
+                    <a:p>
+                      <a:pPr algn="l"/>
+                      <a:r>
+                        <a:rPr sz="1100">
+                          <a:latin typeface="Calibri"/>
+                        </a:rPr>
+                        <a:t>Summary cards</a:t>
+                      </a:r>
+                    </a:p>
+                  </a:txBody>
+                  <a:tcPr>
+                    <a:solidFill>
+                      <a:srgbClr val="FFFFFF"/>
+                    </a:solidFill>
+                  </a:tcPr>
+                </a:tc>
+                <a:tc>
+                  <a:txBody>
+                    <a:bodyPr/>
+                    <a:lstStyle/>
+                    <a:p>
+                      <a:pPr algn="l"/>
+                      <a:r>
+                        <a:rPr sz="1100">
+                          <a:latin typeface="Calibri"/>
+                        </a:rPr>
+                        <a:t>Devices / Total check evals / Passed / Failed / Errors</a:t>
                       </a:r>
                     </a:p>
                   </a:txBody>
@@ -15320,7 +15235,7 @@
                         <a:rPr sz="1100">
                           <a:latin typeface="Calibri"/>
                         </a:rPr>
-                        <a:t>Row style</a:t>
+                        <a:t>Check × device matrix</a:t>
                       </a:r>
                     </a:p>
                   </a:txBody>
@@ -15340,7 +15255,259 @@
                         <a:rPr sz="1100">
                           <a:latin typeface="Calibri"/>
                         </a:rPr>
-                        <a:t>Muted if clean; faded grey if unmatched</a:t>
+                        <a:t>Row per check, column per device — cells PASS / FAIL / ERR / —</a:t>
+                      </a:r>
+                    </a:p>
+                  </a:txBody>
+                  <a:tcPr>
+                    <a:solidFill>
+                      <a:srgbClr val="DBE9F7"/>
+                    </a:solidFill>
+                  </a:tcPr>
+                </a:tc>
+              </a:tr>
+              <a:tr h="347472">
+                <a:tc>
+                  <a:txBody>
+                    <a:bodyPr/>
+                    <a:lstStyle/>
+                    <a:p>
+                      <a:pPr algn="l"/>
+                      <a:r>
+                        <a:rPr sz="1100">
+                          <a:latin typeface="Calibri"/>
+                        </a:rPr>
+                        <a:t>Cell colour-coding</a:t>
+                      </a:r>
+                    </a:p>
+                  </a:txBody>
+                  <a:tcPr>
+                    <a:solidFill>
+                      <a:srgbClr val="FFFFFF"/>
+                    </a:solidFill>
+                  </a:tcPr>
+                </a:tc>
+                <a:tc>
+                  <a:txBody>
+                    <a:bodyPr/>
+                    <a:lstStyle/>
+                    <a:p>
+                      <a:pPr algn="l"/>
+                      <a:r>
+                        <a:rPr sz="1100">
+                          <a:latin typeface="Calibri"/>
+                        </a:rPr>
+                        <a:t>Green = pass  ·  Red = fail  ·  Amber = error  ·  Grey = absent</a:t>
+                      </a:r>
+                    </a:p>
+                  </a:txBody>
+                  <a:tcPr>
+                    <a:solidFill>
+                      <a:srgbClr val="FFFFFF"/>
+                    </a:solidFill>
+                  </a:tcPr>
+                </a:tc>
+              </a:tr>
+              <a:tr h="347472">
+                <a:tc>
+                  <a:txBody>
+                    <a:bodyPr/>
+                    <a:lstStyle/>
+                    <a:p>
+                      <a:pPr algn="l"/>
+                      <a:r>
+                        <a:rPr sz="1100">
+                          <a:latin typeface="Calibri"/>
+                        </a:rPr>
+                        <a:t>Matrix cell links</a:t>
+                      </a:r>
+                    </a:p>
+                  </a:txBody>
+                  <a:tcPr>
+                    <a:solidFill>
+                      <a:srgbClr val="DBE9F7"/>
+                    </a:solidFill>
+                  </a:tcPr>
+                </a:tc>
+                <a:tc>
+                  <a:txBody>
+                    <a:bodyPr/>
+                    <a:lstStyle/>
+                    <a:p>
+                      <a:pPr algn="l"/>
+                      <a:r>
+                        <a:rPr sz="1100">
+                          <a:latin typeface="Calibri"/>
+                        </a:rPr>
+                        <a:t>Click any cell → page jumps to that device's accordion</a:t>
+                      </a:r>
+                    </a:p>
+                  </a:txBody>
+                  <a:tcPr>
+                    <a:solidFill>
+                      <a:srgbClr val="DBE9F7"/>
+                    </a:solidFill>
+                  </a:tcPr>
+                </a:tc>
+              </a:tr>
+              <a:tr h="347472">
+                <a:tc>
+                  <a:txBody>
+                    <a:bodyPr/>
+                    <a:lstStyle/>
+                    <a:p>
+                      <a:pPr algn="l"/>
+                      <a:r>
+                        <a:rPr sz="1100">
+                          <a:latin typeface="Calibri"/>
+                        </a:rPr>
+                        <a:t>Per-device accordions</a:t>
+                      </a:r>
+                    </a:p>
+                  </a:txBody>
+                  <a:tcPr>
+                    <a:solidFill>
+                      <a:srgbClr val="FFFFFF"/>
+                    </a:solidFill>
+                  </a:tcPr>
+                </a:tc>
+                <a:tc>
+                  <a:txBody>
+                    <a:bodyPr/>
+                    <a:lstStyle/>
+                    <a:p>
+                      <a:pPr algn="l"/>
+                      <a:r>
+                        <a:rPr sz="1100">
+                          <a:latin typeface="Calibri"/>
+                        </a:rPr>
+                        <a:t>Click device name → expands full detail inline</a:t>
+                      </a:r>
+                    </a:p>
+                  </a:txBody>
+                  <a:tcPr>
+                    <a:solidFill>
+                      <a:srgbClr val="FFFFFF"/>
+                    </a:solidFill>
+                  </a:tcPr>
+                </a:tc>
+              </a:tr>
+              <a:tr h="347472">
+                <a:tc>
+                  <a:txBody>
+                    <a:bodyPr/>
+                    <a:lstStyle/>
+                    <a:p>
+                      <a:pPr algn="l"/>
+                      <a:r>
+                        <a:rPr sz="1100">
+                          <a:latin typeface="Calibri"/>
+                        </a:rPr>
+                        <a:t>Accordion: checks</a:t>
+                      </a:r>
+                    </a:p>
+                  </a:txBody>
+                  <a:tcPr>
+                    <a:solidFill>
+                      <a:srgbClr val="DBE9F7"/>
+                    </a:solidFill>
+                  </a:tcPr>
+                </a:tc>
+                <a:tc>
+                  <a:txBody>
+                    <a:bodyPr/>
+                    <a:lstStyle/>
+                    <a:p>
+                      <a:pPr algn="l"/>
+                      <a:r>
+                        <a:rPr sz="1100">
+                          <a:latin typeface="Calibri"/>
+                        </a:rPr>
+                        <a:t>Full check result list with pass/fail/warn badges</a:t>
+                      </a:r>
+                    </a:p>
+                  </a:txBody>
+                  <a:tcPr>
+                    <a:solidFill>
+                      <a:srgbClr val="DBE9F7"/>
+                    </a:solidFill>
+                  </a:tcPr>
+                </a:tc>
+              </a:tr>
+              <a:tr h="347472">
+                <a:tc>
+                  <a:txBody>
+                    <a:bodyPr/>
+                    <a:lstStyle/>
+                    <a:p>
+                      <a:pPr algn="l"/>
+                      <a:r>
+                        <a:rPr sz="1100">
+                          <a:latin typeface="Calibri"/>
+                        </a:rPr>
+                        <a:t>Accordion: raw CLI</a:t>
+                      </a:r>
+                    </a:p>
+                  </a:txBody>
+                  <a:tcPr>
+                    <a:solidFill>
+                      <a:srgbClr val="FFFFFF"/>
+                    </a:solidFill>
+                  </a:tcPr>
+                </a:tc>
+                <a:tc>
+                  <a:txBody>
+                    <a:bodyPr/>
+                    <a:lstStyle/>
+                    <a:p>
+                      <a:pPr algn="l"/>
+                      <a:r>
+                        <a:rPr sz="1100">
+                          <a:latin typeface="Calibri"/>
+                        </a:rPr>
+                        <a:t>All command raw outputs with Expand All / Collapse All</a:t>
+                      </a:r>
+                    </a:p>
+                  </a:txBody>
+                  <a:tcPr>
+                    <a:solidFill>
+                      <a:srgbClr val="FFFFFF"/>
+                    </a:solidFill>
+                  </a:tcPr>
+                </a:tc>
+              </a:tr>
+              <a:tr h="347472">
+                <a:tc>
+                  <a:txBody>
+                    <a:bodyPr/>
+                    <a:lstStyle/>
+                    <a:p>
+                      <a:pPr algn="l"/>
+                      <a:r>
+                        <a:rPr sz="1100">
+                          <a:latin typeface="Calibri"/>
+                        </a:rPr>
+                        <a:t>Accordion: parsed JSON</a:t>
+                      </a:r>
+                    </a:p>
+                  </a:txBody>
+                  <a:tcPr>
+                    <a:solidFill>
+                      <a:srgbClr val="DBE9F7"/>
+                    </a:solidFill>
+                  </a:tcPr>
+                </a:tc>
+                <a:tc>
+                  <a:txBody>
+                    <a:bodyPr/>
+                    <a:lstStyle/>
+                    <a:p>
+                      <a:pPr algn="l"/>
+                      <a:r>
+                        <a:rPr sz="1100">
+                          <a:latin typeface="Calibri"/>
+                        </a:rPr>
+                        <a:t>Structured JSON per command; independent Expand All</a:t>
                       </a:r>
                     </a:p>
                   </a:txBody>
@@ -15357,14 +15524,14 @@
       </p:graphicFrame>
       <p:sp>
         <p:nvSpPr>
-          <p:cNvPr id="13" name="TextBox 12"/>
+          <p:cNvPr id="7" name="TextBox 6"/>
           <p:cNvSpPr txBox="1"/>
           <p:nvPr/>
         </p:nvSpPr>
         <p:spPr>
           <a:xfrm>
-            <a:off x="365760" y="6537960"/>
-            <a:ext cx="11430000" cy="411480"/>
+            <a:off x="6080760" y="1097280"/>
+            <a:ext cx="5760720" cy="274320"/>
           </a:xfrm>
           <a:prstGeom prst="rect">
             <a:avLst/>
@@ -15379,54 +15546,38 @@
           <a:p>
             <a:pPr algn="l"/>
             <a:r>
-              <a:rPr sz="1200" b="0" i="1">
-                <a:solidFill>
-                  <a:srgbClr val="444444"/>
+              <a:rPr sz="1300" b="1" i="0">
+                <a:solidFill>
+                  <a:srgbClr val="1A355E"/>
                 </a:solidFill>
                 <a:latin typeface="Calibri"/>
               </a:rPr>
-              <a:t>health-all produces ONE combined HTML (no per-device files, no index).  delta-all produces per-device HTMLs + index.html.</a:t>
-            </a:r>
-          </a:p>
-        </p:txBody>
-      </p:sp>
-    </p:spTree>
-  </p:cSld>
-  <p:clrMapOvr>
-    <a:masterClrMapping/>
-  </p:clrMapOvr>
-</p:sld>
-</file>
-
-<file path=ppt/slides/slide23.xml><?xml version="1.0" encoding="utf-8"?>
-<p:sld xmlns:a="http://schemas.openxmlformats.org/drawingml/2006/main" xmlns:p="http://schemas.openxmlformats.org/presentationml/2006/main" xmlns:r="http://schemas.openxmlformats.org/officeDocument/2006/relationships">
-  <p:cSld>
-    <p:spTree>
-      <p:nvGrpSpPr>
-        <p:cNvPr id="1" name=""/>
-        <p:cNvGrpSpPr/>
-        <p:nvPr/>
-      </p:nvGrpSpPr>
-      <p:grpSpPr/>
-      <p:sp>
-        <p:nvSpPr>
-          <p:cNvPr id="2" name="Rectangle 1"/>
+              <a:t>CLI invocation</a:t>
+            </a:r>
+          </a:p>
+        </p:txBody>
+      </p:sp>
+      <p:sp>
+        <p:nvSpPr>
+          <p:cNvPr id="8" name="Rectangle 7"/>
           <p:cNvSpPr/>
           <p:nvPr/>
         </p:nvSpPr>
         <p:spPr>
           <a:xfrm>
-            <a:off x="0" y="0"/>
-            <a:ext cx="12188952" cy="1005840"/>
+            <a:off x="6080760" y="1417320"/>
+            <a:ext cx="5760720" cy="3017520"/>
           </a:xfrm>
           <a:prstGeom prst="rect">
             <a:avLst/>
           </a:prstGeom>
           <a:solidFill>
-            <a:srgbClr val="1A355E"/>
+            <a:srgbClr val="EEF2F7"/>
           </a:solidFill>
-          <a:ln>
-            <a:noFill/>
+          <a:ln w="6350">
+            <a:solidFill>
+              <a:srgbClr val="CCCCCC"/>
+            </a:solidFill>
           </a:ln>
         </p:spPr>
         <p:style>
@@ -15453,14 +15604,202 @@
       </p:sp>
       <p:sp>
         <p:nvSpPr>
-          <p:cNvPr id="3" name="TextBox 2"/>
+          <p:cNvPr id="9" name="TextBox 8"/>
           <p:cNvSpPr txBox="1"/>
           <p:nvPr/>
         </p:nvSpPr>
         <p:spPr>
           <a:xfrm>
-            <a:off x="320040" y="91440"/>
-            <a:ext cx="11430000" cy="594360"/>
+            <a:off x="6190488" y="1490472"/>
+            <a:ext cx="5541264" cy="2871216"/>
+          </a:xfrm>
+          <a:prstGeom prst="rect">
+            <a:avLst/>
+          </a:prstGeom>
+          <a:noFill/>
+        </p:spPr>
+        <p:txBody>
+          <a:bodyPr wrap="none">
+            <a:spAutoFit/>
+          </a:bodyPr>
+          <a:lstStyle/>
+          <a:p>
+            <a:r>
+              <a:rPr sz="1000">
+                <a:solidFill>
+                  <a:srgbClr val="444444"/>
+                </a:solidFill>
+                <a:latin typeface="Courier New"/>
+              </a:rPr>
+              <a:t># Minimal — HTML only</a:t>
+            </a:r>
+          </a:p>
+          <a:p>
+            <a:r>
+              <a:rPr sz="1000">
+                <a:solidFill>
+                  <a:srgbClr val="444444"/>
+                </a:solidFill>
+                <a:latin typeface="Courier New"/>
+              </a:rPr>
+              <a:t>python report.py health-all \</a:t>
+            </a:r>
+          </a:p>
+          <a:p>
+            <a:r>
+              <a:rPr sz="1000">
+                <a:solidFill>
+                  <a:srgbClr val="444444"/>
+                </a:solidFill>
+                <a:latin typeface="Courier New"/>
+              </a:rPr>
+              <a:t>  --dir              data/json/ \</a:t>
+            </a:r>
+          </a:p>
+          <a:p>
+            <a:r>
+              <a:rPr sz="1000">
+                <a:solidFill>
+                  <a:srgbClr val="444444"/>
+                </a:solidFill>
+                <a:latin typeface="Courier New"/>
+              </a:rPr>
+              <a:t>  --default-checks   checks/base.yaml \</a:t>
+            </a:r>
+          </a:p>
+          <a:p>
+            <a:r>
+              <a:rPr sz="1000">
+                <a:solidFill>
+                  <a:srgbClr val="444444"/>
+                </a:solidFill>
+                <a:latin typeface="Courier New"/>
+              </a:rPr>
+              <a:t>  --output-dir       reports/health/</a:t>
+            </a:r>
+          </a:p>
+          <a:p>
+            <a:r>
+              <a:rPr sz="1000">
+                <a:solidFill>
+                  <a:srgbClr val="444444"/>
+                </a:solidFill>
+                <a:latin typeface="Courier New"/>
+              </a:rPr>
+              <a:t># → reports/health/health_report.html</a:t>
+            </a:r>
+          </a:p>
+          <a:p>
+            <a:r>
+              <a:rPr sz="1000">
+                <a:solidFill>
+                  <a:srgbClr val="444444"/>
+                </a:solidFill>
+                <a:latin typeface="Courier New"/>
+              </a:rPr>
+              <a:t/>
+            </a:r>
+          </a:p>
+          <a:p>
+            <a:r>
+              <a:rPr sz="1000">
+                <a:solidFill>
+                  <a:srgbClr val="444444"/>
+                </a:solidFill>
+                <a:latin typeface="Courier New"/>
+              </a:rPr>
+              <a:t># With per-device JSON files as well</a:t>
+            </a:r>
+          </a:p>
+          <a:p>
+            <a:r>
+              <a:rPr sz="1000">
+                <a:solidFill>
+                  <a:srgbClr val="444444"/>
+                </a:solidFill>
+                <a:latin typeface="Courier New"/>
+              </a:rPr>
+              <a:t>python report.py health-all \</a:t>
+            </a:r>
+          </a:p>
+          <a:p>
+            <a:r>
+              <a:rPr sz="1000">
+                <a:solidFill>
+                  <a:srgbClr val="444444"/>
+                </a:solidFill>
+                <a:latin typeface="Courier New"/>
+              </a:rPr>
+              <a:t>  --dir              data/json/ \</a:t>
+            </a:r>
+          </a:p>
+          <a:p>
+            <a:r>
+              <a:rPr sz="1000">
+                <a:solidFill>
+                  <a:srgbClr val="444444"/>
+                </a:solidFill>
+                <a:latin typeface="Courier New"/>
+              </a:rPr>
+              <a:t>  --default-checks   checks/base.yaml \</a:t>
+            </a:r>
+          </a:p>
+          <a:p>
+            <a:r>
+              <a:rPr sz="1000">
+                <a:solidFill>
+                  <a:srgbClr val="444444"/>
+                </a:solidFill>
+                <a:latin typeface="Courier New"/>
+              </a:rPr>
+              <a:t>  --device-checks-dir checks/devices/ \</a:t>
+            </a:r>
+          </a:p>
+          <a:p>
+            <a:r>
+              <a:rPr sz="1000">
+                <a:solidFill>
+                  <a:srgbClr val="444444"/>
+                </a:solidFill>
+                <a:latin typeface="Courier New"/>
+              </a:rPr>
+              <a:t>  --output-dir       reports/health/ \</a:t>
+            </a:r>
+          </a:p>
+          <a:p>
+            <a:r>
+              <a:rPr sz="1000">
+                <a:solidFill>
+                  <a:srgbClr val="444444"/>
+                </a:solidFill>
+                <a:latin typeface="Courier New"/>
+              </a:rPr>
+              <a:t>  --format           both</a:t>
+            </a:r>
+          </a:p>
+          <a:p>
+            <a:r>
+              <a:rPr sz="1000">
+                <a:solidFill>
+                  <a:srgbClr val="444444"/>
+                </a:solidFill>
+                <a:latin typeface="Courier New"/>
+              </a:rPr>
+              <a:t># → health_report.html  +  {hostname}_health.json</a:t>
+            </a:r>
+          </a:p>
+        </p:txBody>
+      </p:sp>
+      <p:sp>
+        <p:nvSpPr>
+          <p:cNvPr id="10" name="TextBox 9"/>
+          <p:cNvSpPr txBox="1"/>
+          <p:nvPr/>
+        </p:nvSpPr>
+        <p:spPr>
+          <a:xfrm>
+            <a:off x="6080760" y="4526280"/>
+            <a:ext cx="5760720" cy="274320"/>
           </a:xfrm>
           <a:prstGeom prst="rect">
             <a:avLst/>
@@ -15475,27 +15814,27 @@
           <a:p>
             <a:pPr algn="l"/>
             <a:r>
-              <a:rPr sz="2400" b="1" i="0">
-                <a:solidFill>
-                  <a:srgbClr val="FFFFFF"/>
+              <a:rPr sz="1300" b="1" i="0">
+                <a:solidFill>
+                  <a:srgbClr val="1A355E"/>
                 </a:solidFill>
                 <a:latin typeface="Calibri"/>
               </a:rPr>
-              <a:t>Snapshot Collector  (report.py collect)</a:t>
-            </a:r>
-          </a:p>
-        </p:txBody>
-      </p:sp>
-      <p:sp>
-        <p:nvSpPr>
-          <p:cNvPr id="4" name="TextBox 3"/>
+              <a:t>Key behaviours</a:t>
+            </a:r>
+          </a:p>
+        </p:txBody>
+      </p:sp>
+      <p:sp>
+        <p:nvSpPr>
+          <p:cNvPr id="11" name="TextBox 10"/>
           <p:cNvSpPr txBox="1"/>
           <p:nvPr/>
         </p:nvSpPr>
         <p:spPr>
           <a:xfrm>
-            <a:off x="320040" y="658368"/>
-            <a:ext cx="11430000" cy="292608"/>
+            <a:off x="6080760" y="4846320"/>
+            <a:ext cx="5760720" cy="2011680"/>
           </a:xfrm>
           <a:prstGeom prst="rect">
             <a:avLst/>
@@ -15508,75 +15847,124 @@
           </a:bodyPr>
           <a:lstStyle/>
           <a:p>
-            <a:pPr algn="l"/>
-            <a:r>
-              <a:rPr sz="1300" b="0" i="0">
-                <a:solidFill>
-                  <a:srgbClr val="CCDDF0"/>
+            <a:pPr>
+              <a:spcAft>
+                <a:spcPts val="200"/>
+              </a:spcAft>
+            </a:pPr>
+            <a:r>
+              <a:rPr sz="1150">
+                <a:solidFill>
+                  <a:srgbClr val="222222"/>
                 </a:solidFill>
                 <a:latin typeface="Calibri"/>
               </a:rPr>
-              <a:t>Full pipeline: from live device to JSON snapshot — no main.py call needed</a:t>
-            </a:r>
-          </a:p>
-        </p:txBody>
-      </p:sp>
-      <p:sp>
-        <p:nvSpPr>
-          <p:cNvPr id="5" name="TextBox 4"/>
-          <p:cNvSpPr txBox="1"/>
-          <p:nvPr/>
-        </p:nvSpPr>
-        <p:spPr>
-          <a:xfrm>
-            <a:off x="365760" y="1097280"/>
-            <a:ext cx="5486400" cy="274320"/>
-          </a:xfrm>
-          <a:prstGeom prst="rect">
-            <a:avLst/>
-          </a:prstGeom>
-          <a:noFill/>
-        </p:spPr>
-        <p:txBody>
-          <a:bodyPr wrap="square">
-            <a:spAutoFit/>
-          </a:bodyPr>
-          <a:lstStyle/>
-          <a:p>
-            <a:pPr algn="l"/>
-            <a:r>
-              <a:rPr sz="1300" b="1" i="0">
-                <a:solidFill>
-                  <a:srgbClr val="1A355E"/>
+              <a:t>▸ Single HTML — no per-device files, no index.html</a:t>
+            </a:r>
+          </a:p>
+          <a:p>
+            <a:pPr>
+              <a:spcAft>
+                <a:spcPts val="200"/>
+              </a:spcAft>
+            </a:pPr>
+            <a:r>
+              <a:rPr sz="1150">
+                <a:solidFill>
+                  <a:srgbClr val="222222"/>
                 </a:solidFill>
                 <a:latin typeface="Calibri"/>
               </a:rPr>
-              <a:t>Offline mode (no SSH needed)</a:t>
-            </a:r>
-          </a:p>
-        </p:txBody>
-      </p:sp>
-      <p:sp>
-        <p:nvSpPr>
-          <p:cNvPr id="6" name="Rectangle 5"/>
+              <a:t>▸ Device-specific YAML (--device-checks-dir) overrides default checks by name</a:t>
+            </a:r>
+          </a:p>
+          <a:p>
+            <a:pPr>
+              <a:spcAft>
+                <a:spcPts val="200"/>
+              </a:spcAft>
+            </a:pPr>
+            <a:r>
+              <a:rPr sz="1150">
+                <a:solidFill>
+                  <a:srgbClr val="222222"/>
+                </a:solidFill>
+                <a:latin typeface="Calibri"/>
+              </a:rPr>
+              <a:t>▸ Exit code 1 if any critical check fails across any device</a:t>
+            </a:r>
+          </a:p>
+          <a:p>
+            <a:pPr>
+              <a:spcAft>
+                <a:spcPts val="200"/>
+              </a:spcAft>
+            </a:pPr>
+            <a:r>
+              <a:rPr sz="1150">
+                <a:solidFill>
+                  <a:srgbClr val="222222"/>
+                </a:solidFill>
+                <a:latin typeface="Calibri"/>
+              </a:rPr>
+              <a:t>▸ Matrix columns truncated at 15 chars with full name in tooltip</a:t>
+            </a:r>
+          </a:p>
+          <a:p>
+            <a:pPr>
+              <a:spcAft>
+                <a:spcPts val="200"/>
+              </a:spcAft>
+            </a:pPr>
+            <a:r>
+              <a:rPr sz="1150">
+                <a:solidFill>
+                  <a:srgbClr val="222222"/>
+                </a:solidFill>
+                <a:latin typeface="Calibri"/>
+              </a:rPr>
+              <a:t>▸ Raw CLI and Parsed JSON toolbars are independent (separate JS functions)</a:t>
+            </a:r>
+          </a:p>
+        </p:txBody>
+      </p:sp>
+    </p:spTree>
+  </p:cSld>
+  <p:clrMapOvr>
+    <a:masterClrMapping/>
+  </p:clrMapOvr>
+</p:sld>
+</file>
+
+<file path=ppt/slides/slide24.xml><?xml version="1.0" encoding="utf-8"?>
+<p:sld xmlns:a="http://schemas.openxmlformats.org/drawingml/2006/main" xmlns:p="http://schemas.openxmlformats.org/presentationml/2006/main" xmlns:r="http://schemas.openxmlformats.org/officeDocument/2006/relationships">
+  <p:cSld>
+    <p:spTree>
+      <p:nvGrpSpPr>
+        <p:cNvPr id="1" name=""/>
+        <p:cNvGrpSpPr/>
+        <p:nvPr/>
+      </p:nvGrpSpPr>
+      <p:grpSpPr/>
+      <p:sp>
+        <p:nvSpPr>
+          <p:cNvPr id="2" name="Rectangle 1"/>
           <p:cNvSpPr/>
           <p:nvPr/>
         </p:nvSpPr>
         <p:spPr>
           <a:xfrm>
-            <a:off x="365760" y="1417320"/>
-            <a:ext cx="5486400" cy="1737360"/>
+            <a:off x="0" y="0"/>
+            <a:ext cx="12188952" cy="1005840"/>
           </a:xfrm>
           <a:prstGeom prst="rect">
             <a:avLst/>
           </a:prstGeom>
           <a:solidFill>
-            <a:srgbClr val="EEF2F7"/>
+            <a:srgbClr val="1A355E"/>
           </a:solidFill>
-          <a:ln w="6350">
-            <a:solidFill>
-              <a:srgbClr val="CCCCCC"/>
-            </a:solidFill>
+          <a:ln>
+            <a:noFill/>
           </a:ln>
         </p:spPr>
         <p:style>
@@ -15603,103 +15991,14 @@
       </p:sp>
       <p:sp>
         <p:nvSpPr>
-          <p:cNvPr id="7" name="TextBox 6"/>
+          <p:cNvPr id="3" name="TextBox 2"/>
           <p:cNvSpPr txBox="1"/>
           <p:nvPr/>
         </p:nvSpPr>
         <p:spPr>
           <a:xfrm>
-            <a:off x="475488" y="1490472"/>
-            <a:ext cx="5266944" cy="1591056"/>
-          </a:xfrm>
-          <a:prstGeom prst="rect">
-            <a:avLst/>
-          </a:prstGeom>
-          <a:noFill/>
-        </p:spPr>
-        <p:txBody>
-          <a:bodyPr wrap="none">
-            <a:spAutoFit/>
-          </a:bodyPr>
-          <a:lstStyle/>
-          <a:p>
-            <a:r>
-              <a:rPr sz="1050">
-                <a:solidFill>
-                  <a:srgbClr val="444444"/>
-                </a:solidFill>
-                <a:latin typeface="Courier New"/>
-              </a:rPr>
-              <a:t># Process existing .txt CLI dumps</a:t>
-            </a:r>
-          </a:p>
-          <a:p>
-            <a:r>
-              <a:rPr sz="1050">
-                <a:solidFill>
-                  <a:srgbClr val="444444"/>
-                </a:solidFill>
-                <a:latin typeface="Courier New"/>
-              </a:rPr>
-              <a:t>python report.py collect \</a:t>
-            </a:r>
-          </a:p>
-          <a:p>
-            <a:r>
-              <a:rPr sz="1050">
-                <a:solidFill>
-                  <a:srgbClr val="444444"/>
-                </a:solidFill>
-                <a:latin typeface="Courier New"/>
-              </a:rPr>
-              <a:t>  --from-dir   data/raw/ \</a:t>
-            </a:r>
-          </a:p>
-          <a:p>
-            <a:r>
-              <a:rPr sz="1050">
-                <a:solidFill>
-                  <a:srgbClr val="444444"/>
-                </a:solidFill>
-                <a:latin typeface="Courier New"/>
-              </a:rPr>
-              <a:t>  --output-dir data/json/</a:t>
-            </a:r>
-          </a:p>
-          <a:p>
-            <a:r>
-              <a:rPr sz="1050">
-                <a:solidFill>
-                  <a:srgbClr val="444444"/>
-                </a:solidFill>
-                <a:latin typeface="Courier New"/>
-              </a:rPr>
-              <a:t/>
-            </a:r>
-          </a:p>
-          <a:p>
-            <a:r>
-              <a:rPr sz="1050">
-                <a:solidFill>
-                  <a:srgbClr val="444444"/>
-                </a:solidFill>
-                <a:latin typeface="Courier New"/>
-              </a:rPr>
-              <a:t># Same parsing pipeline as main.py</a:t>
-            </a:r>
-          </a:p>
-        </p:txBody>
-      </p:sp>
-      <p:sp>
-        <p:nvSpPr>
-          <p:cNvPr id="8" name="TextBox 7"/>
-          <p:cNvSpPr txBox="1"/>
-          <p:nvPr/>
-        </p:nvSpPr>
-        <p:spPr>
-          <a:xfrm>
-            <a:off x="365760" y="3246120"/>
-            <a:ext cx="5486400" cy="274320"/>
+            <a:off x="320040" y="91440"/>
+            <a:ext cx="11430000" cy="594360"/>
           </a:xfrm>
           <a:prstGeom prst="rect">
             <a:avLst/>
@@ -15714,27 +16013,97 @@
           <a:p>
             <a:pPr algn="l"/>
             <a:r>
+              <a:rPr sz="2400" b="1" i="0">
+                <a:solidFill>
+                  <a:srgbClr val="FFFFFF"/>
+                </a:solidFill>
+                <a:latin typeface="Calibri"/>
+              </a:rPr>
+              <a:t>Snapshot Collector  (report.py collect)</a:t>
+            </a:r>
+          </a:p>
+        </p:txBody>
+      </p:sp>
+      <p:sp>
+        <p:nvSpPr>
+          <p:cNvPr id="4" name="TextBox 3"/>
+          <p:cNvSpPr txBox="1"/>
+          <p:nvPr/>
+        </p:nvSpPr>
+        <p:spPr>
+          <a:xfrm>
+            <a:off x="320040" y="658368"/>
+            <a:ext cx="11430000" cy="292608"/>
+          </a:xfrm>
+          <a:prstGeom prst="rect">
+            <a:avLst/>
+          </a:prstGeom>
+          <a:noFill/>
+        </p:spPr>
+        <p:txBody>
+          <a:bodyPr wrap="square">
+            <a:spAutoFit/>
+          </a:bodyPr>
+          <a:lstStyle/>
+          <a:p>
+            <a:pPr algn="l"/>
+            <a:r>
+              <a:rPr sz="1300" b="0" i="0">
+                <a:solidFill>
+                  <a:srgbClr val="CCDDF0"/>
+                </a:solidFill>
+                <a:latin typeface="Calibri"/>
+              </a:rPr>
+              <a:t>Full pipeline: from live device to JSON snapshot — no main.py call needed</a:t>
+            </a:r>
+          </a:p>
+        </p:txBody>
+      </p:sp>
+      <p:sp>
+        <p:nvSpPr>
+          <p:cNvPr id="5" name="TextBox 4"/>
+          <p:cNvSpPr txBox="1"/>
+          <p:nvPr/>
+        </p:nvSpPr>
+        <p:spPr>
+          <a:xfrm>
+            <a:off x="365760" y="1097280"/>
+            <a:ext cx="5486400" cy="274320"/>
+          </a:xfrm>
+          <a:prstGeom prst="rect">
+            <a:avLst/>
+          </a:prstGeom>
+          <a:noFill/>
+        </p:spPr>
+        <p:txBody>
+          <a:bodyPr wrap="square">
+            <a:spAutoFit/>
+          </a:bodyPr>
+          <a:lstStyle/>
+          <a:p>
+            <a:pPr algn="l"/>
+            <a:r>
               <a:rPr sz="1300" b="1" i="0">
                 <a:solidFill>
                   <a:srgbClr val="1A355E"/>
                 </a:solidFill>
                 <a:latin typeface="Calibri"/>
               </a:rPr>
-              <a:t>SSH mode (requires  pip install netmiko)</a:t>
-            </a:r>
-          </a:p>
-        </p:txBody>
-      </p:sp>
-      <p:sp>
-        <p:nvSpPr>
-          <p:cNvPr id="9" name="Rectangle 8"/>
+              <a:t>Offline mode (no SSH needed)</a:t>
+            </a:r>
+          </a:p>
+        </p:txBody>
+      </p:sp>
+      <p:sp>
+        <p:nvSpPr>
+          <p:cNvPr id="6" name="Rectangle 5"/>
           <p:cNvSpPr/>
           <p:nvPr/>
         </p:nvSpPr>
         <p:spPr>
           <a:xfrm>
-            <a:off x="365760" y="3566160"/>
-            <a:ext cx="5486400" cy="1691640"/>
+            <a:off x="365760" y="1417320"/>
+            <a:ext cx="5486400" cy="1737360"/>
           </a:xfrm>
           <a:prstGeom prst="rect">
             <a:avLst/>
@@ -15772,14 +16141,14 @@
       </p:sp>
       <p:sp>
         <p:nvSpPr>
-          <p:cNvPr id="10" name="TextBox 9"/>
+          <p:cNvPr id="7" name="TextBox 6"/>
           <p:cNvSpPr txBox="1"/>
           <p:nvPr/>
         </p:nvSpPr>
         <p:spPr>
           <a:xfrm>
-            <a:off x="475488" y="3639312"/>
-            <a:ext cx="5266944" cy="1545336"/>
+            <a:off x="475488" y="1490472"/>
+            <a:ext cx="5266944" cy="1591056"/>
           </a:xfrm>
           <a:prstGeom prst="rect">
             <a:avLst/>
@@ -15799,6 +16168,17 @@
                 </a:solidFill>
                 <a:latin typeface="Courier New"/>
               </a:rPr>
+              <a:t># Process existing .txt CLI dumps</a:t>
+            </a:r>
+          </a:p>
+          <a:p>
+            <a:r>
+              <a:rPr sz="1050">
+                <a:solidFill>
+                  <a:srgbClr val="444444"/>
+                </a:solidFill>
+                <a:latin typeface="Courier New"/>
+              </a:rPr>
               <a:t>python report.py collect \</a:t>
             </a:r>
           </a:p>
@@ -15810,54 +16190,54 @@
                 </a:solidFill>
                 <a:latin typeface="Courier New"/>
               </a:rPr>
-              <a:t>  --devices    devices.yaml \</a:t>
-            </a:r>
-          </a:p>
-          <a:p>
-            <a:r>
-              <a:rPr sz="1050">
-                <a:solidFill>
-                  <a:srgbClr val="444444"/>
-                </a:solidFill>
-                <a:latin typeface="Courier New"/>
-              </a:rPr>
-              <a:t>  --raw-dir    data/raw/      # optional .txt dumps</a:t>
-            </a:r>
-          </a:p>
-          <a:p>
-            <a:r>
-              <a:rPr sz="1050">
-                <a:solidFill>
-                  <a:srgbClr val="444444"/>
-                </a:solidFill>
-                <a:latin typeface="Courier New"/>
-              </a:rPr>
-              <a:t>  --output-dir data/json/ \</a:t>
-            </a:r>
-          </a:p>
-          <a:p>
-            <a:r>
-              <a:rPr sz="1050">
-                <a:solidFill>
-                  <a:srgbClr val="444444"/>
-                </a:solidFill>
-                <a:latin typeface="Courier New"/>
-              </a:rPr>
-              <a:t>  --password   &lt;pw&gt;</a:t>
-            </a:r>
-          </a:p>
-        </p:txBody>
-      </p:sp>
-      <p:sp>
-        <p:nvSpPr>
-          <p:cNvPr id="11" name="TextBox 10"/>
+              <a:t>  --from-dir   data/raw/ \</a:t>
+            </a:r>
+          </a:p>
+          <a:p>
+            <a:r>
+              <a:rPr sz="1050">
+                <a:solidFill>
+                  <a:srgbClr val="444444"/>
+                </a:solidFill>
+                <a:latin typeface="Courier New"/>
+              </a:rPr>
+              <a:t>  --output-dir data/json/</a:t>
+            </a:r>
+          </a:p>
+          <a:p>
+            <a:r>
+              <a:rPr sz="1050">
+                <a:solidFill>
+                  <a:srgbClr val="444444"/>
+                </a:solidFill>
+                <a:latin typeface="Courier New"/>
+              </a:rPr>
+              <a:t/>
+            </a:r>
+          </a:p>
+          <a:p>
+            <a:r>
+              <a:rPr sz="1050">
+                <a:solidFill>
+                  <a:srgbClr val="444444"/>
+                </a:solidFill>
+                <a:latin typeface="Courier New"/>
+              </a:rPr>
+              <a:t># Same parsing pipeline as main.py</a:t>
+            </a:r>
+          </a:p>
+        </p:txBody>
+      </p:sp>
+      <p:sp>
+        <p:nvSpPr>
+          <p:cNvPr id="8" name="TextBox 7"/>
           <p:cNvSpPr txBox="1"/>
           <p:nvPr/>
         </p:nvSpPr>
         <p:spPr>
           <a:xfrm>
-            <a:off x="6080760" y="1097280"/>
-            <a:ext cx="5760720" cy="274320"/>
+            <a:off x="365760" y="3246120"/>
+            <a:ext cx="5486400" cy="274320"/>
           </a:xfrm>
           <a:prstGeom prst="rect">
             <a:avLst/>
@@ -15878,21 +16258,21 @@
                 </a:solidFill>
                 <a:latin typeface="Calibri"/>
               </a:rPr>
-              <a:t>devices.yaml format</a:t>
-            </a:r>
-          </a:p>
-        </p:txBody>
-      </p:sp>
-      <p:sp>
-        <p:nvSpPr>
-          <p:cNvPr id="12" name="Rectangle 11"/>
+              <a:t>SSH mode (requires  pip install netmiko)</a:t>
+            </a:r>
+          </a:p>
+        </p:txBody>
+      </p:sp>
+      <p:sp>
+        <p:nvSpPr>
+          <p:cNvPr id="9" name="Rectangle 8"/>
           <p:cNvSpPr/>
           <p:nvPr/>
         </p:nvSpPr>
         <p:spPr>
           <a:xfrm>
-            <a:off x="6080760" y="1417320"/>
-            <a:ext cx="5760720" cy="3383280"/>
+            <a:off x="365760" y="3566160"/>
+            <a:ext cx="5486400" cy="1691640"/>
           </a:xfrm>
           <a:prstGeom prst="rect">
             <a:avLst/>
@@ -15930,14 +16310,14 @@
       </p:sp>
       <p:sp>
         <p:nvSpPr>
-          <p:cNvPr id="13" name="TextBox 12"/>
+          <p:cNvPr id="10" name="TextBox 9"/>
           <p:cNvSpPr txBox="1"/>
           <p:nvPr/>
         </p:nvSpPr>
         <p:spPr>
           <a:xfrm>
-            <a:off x="6190488" y="1490472"/>
-            <a:ext cx="5541264" cy="3236976"/>
+            <a:off x="475488" y="3639312"/>
+            <a:ext cx="5266944" cy="1545336"/>
           </a:xfrm>
           <a:prstGeom prst="rect">
             <a:avLst/>
@@ -15957,241 +16337,65 @@
                 </a:solidFill>
                 <a:latin typeface="Courier New"/>
               </a:rPr>
-              <a:t>defaults:</a:t>
-            </a:r>
-          </a:p>
-          <a:p>
-            <a:r>
-              <a:rPr sz="1050">
-                <a:solidFill>
-                  <a:srgbClr val="444444"/>
-                </a:solidFill>
-                <a:latin typeface="Courier New"/>
-              </a:rPr>
-              <a:t>  username: admin</a:t>
-            </a:r>
-          </a:p>
-          <a:p>
-            <a:r>
-              <a:rPr sz="1050">
-                <a:solidFill>
-                  <a:srgbClr val="444444"/>
-                </a:solidFill>
-                <a:latin typeface="Courier New"/>
-              </a:rPr>
-              <a:t>  password: ""      # leave blank, use --password</a:t>
-            </a:r>
-          </a:p>
-          <a:p>
-            <a:r>
-              <a:rPr sz="1050">
-                <a:solidFill>
-                  <a:srgbClr val="444444"/>
-                </a:solidFill>
-                <a:latin typeface="Courier New"/>
-              </a:rPr>
-              <a:t>  timeout: 30</a:t>
-            </a:r>
-          </a:p>
-          <a:p>
-            <a:r>
-              <a:rPr sz="1050">
-                <a:solidFill>
-                  <a:srgbClr val="444444"/>
-                </a:solidFill>
-                <a:latin typeface="Courier New"/>
-              </a:rPr>
-              <a:t/>
-            </a:r>
-          </a:p>
-          <a:p>
-            <a:r>
-              <a:rPr sz="1050">
-                <a:solidFill>
-                  <a:srgbClr val="444444"/>
-                </a:solidFill>
-                <a:latin typeface="Courier New"/>
-              </a:rPr>
-              <a:t>devices:</a:t>
-            </a:r>
-          </a:p>
-          <a:p>
-            <a:r>
-              <a:rPr sz="1050">
-                <a:solidFill>
-                  <a:srgbClr val="444444"/>
-                </a:solidFill>
-                <a:latin typeface="Courier New"/>
-              </a:rPr>
-              <a:t>  - hostname: N9K-CAMA-WAN-1</a:t>
-            </a:r>
-          </a:p>
-          <a:p>
-            <a:r>
-              <a:rPr sz="1050">
-                <a:solidFill>
-                  <a:srgbClr val="444444"/>
-                </a:solidFill>
-                <a:latin typeface="Courier New"/>
-              </a:rPr>
-              <a:t>    host: 192.168.1.1</a:t>
-            </a:r>
-          </a:p>
-          <a:p>
-            <a:r>
-              <a:rPr sz="1050">
-                <a:solidFill>
-                  <a:srgbClr val="444444"/>
-                </a:solidFill>
-                <a:latin typeface="Courier New"/>
-              </a:rPr>
-              <a:t>    platform: cisco_nxos</a:t>
-            </a:r>
-          </a:p>
-          <a:p>
-            <a:r>
-              <a:rPr sz="1050">
-                <a:solidFill>
-                  <a:srgbClr val="444444"/>
-                </a:solidFill>
-                <a:latin typeface="Courier New"/>
-              </a:rPr>
-              <a:t/>
-            </a:r>
-          </a:p>
-          <a:p>
-            <a:r>
-              <a:rPr sz="1050">
-                <a:solidFill>
-                  <a:srgbClr val="444444"/>
-                </a:solidFill>
-                <a:latin typeface="Courier New"/>
-              </a:rPr>
-              <a:t>  - hostname: IOS-RTR-1</a:t>
-            </a:r>
-          </a:p>
-          <a:p>
-            <a:r>
-              <a:rPr sz="1050">
-                <a:solidFill>
-                  <a:srgbClr val="444444"/>
-                </a:solidFill>
-                <a:latin typeface="Courier New"/>
-              </a:rPr>
-              <a:t>    host: 10.0.0.1</a:t>
-            </a:r>
-          </a:p>
-          <a:p>
-            <a:r>
-              <a:rPr sz="1050">
-                <a:solidFill>
-                  <a:srgbClr val="444444"/>
-                </a:solidFill>
-                <a:latin typeface="Courier New"/>
-              </a:rPr>
-              <a:t>    platform: cisco_ios</a:t>
-            </a:r>
-          </a:p>
-          <a:p>
-            <a:r>
-              <a:rPr sz="1050">
-                <a:solidFill>
-                  <a:srgbClr val="444444"/>
-                </a:solidFill>
-                <a:latin typeface="Courier New"/>
-              </a:rPr>
-              <a:t>    username: ops        # override defaults</a:t>
-            </a:r>
-          </a:p>
-          <a:p>
-            <a:r>
-              <a:rPr sz="1050">
-                <a:solidFill>
-                  <a:srgbClr val="444444"/>
-                </a:solidFill>
-                <a:latin typeface="Courier New"/>
-              </a:rPr>
-              <a:t/>
-            </a:r>
-          </a:p>
-          <a:p>
-            <a:r>
-              <a:rPr sz="1050">
-                <a:solidFill>
-                  <a:srgbClr val="444444"/>
-                </a:solidFill>
-                <a:latin typeface="Courier New"/>
-              </a:rPr>
-              <a:t>  - hostname: N9K-CAMA-WAN-2</a:t>
-            </a:r>
-          </a:p>
-          <a:p>
-            <a:r>
-              <a:rPr sz="1050">
-                <a:solidFill>
-                  <a:srgbClr val="444444"/>
-                </a:solidFill>
-                <a:latin typeface="Courier New"/>
-              </a:rPr>
-              <a:t>    host: 192.168.1.2</a:t>
-            </a:r>
-          </a:p>
-          <a:p>
-            <a:r>
-              <a:rPr sz="1050">
-                <a:solidFill>
-                  <a:srgbClr val="444444"/>
-                </a:solidFill>
-                <a:latin typeface="Courier New"/>
-              </a:rPr>
-              <a:t>    platform: cisco_nxos</a:t>
-            </a:r>
-          </a:p>
-          <a:p>
-            <a:r>
-              <a:rPr sz="1050">
-                <a:solidFill>
-                  <a:srgbClr val="444444"/>
-                </a:solidFill>
-                <a:latin typeface="Courier New"/>
-              </a:rPr>
-              <a:t>    commands:            # explicit list (overrides registry)</a:t>
-            </a:r>
-          </a:p>
-          <a:p>
-            <a:r>
-              <a:rPr sz="1050">
-                <a:solidFill>
-                  <a:srgbClr val="444444"/>
-                </a:solidFill>
-                <a:latin typeface="Courier New"/>
-              </a:rPr>
-              <a:t>      - show version</a:t>
-            </a:r>
-          </a:p>
-          <a:p>
-            <a:r>
-              <a:rPr sz="1050">
-                <a:solidFill>
-                  <a:srgbClr val="444444"/>
-                </a:solidFill>
-                <a:latin typeface="Courier New"/>
-              </a:rPr>
-              <a:t>      - show ip bgp summary vrf all</a:t>
-            </a:r>
-          </a:p>
-        </p:txBody>
-      </p:sp>
-      <p:sp>
-        <p:nvSpPr>
-          <p:cNvPr id="14" name="TextBox 13"/>
+              <a:t>python report.py collect \</a:t>
+            </a:r>
+          </a:p>
+          <a:p>
+            <a:r>
+              <a:rPr sz="1050">
+                <a:solidFill>
+                  <a:srgbClr val="444444"/>
+                </a:solidFill>
+                <a:latin typeface="Courier New"/>
+              </a:rPr>
+              <a:t>  --devices    devices.yaml \</a:t>
+            </a:r>
+          </a:p>
+          <a:p>
+            <a:r>
+              <a:rPr sz="1050">
+                <a:solidFill>
+                  <a:srgbClr val="444444"/>
+                </a:solidFill>
+                <a:latin typeface="Courier New"/>
+              </a:rPr>
+              <a:t>  --raw-dir    data/raw/      # optional .txt dumps</a:t>
+            </a:r>
+          </a:p>
+          <a:p>
+            <a:r>
+              <a:rPr sz="1050">
+                <a:solidFill>
+                  <a:srgbClr val="444444"/>
+                </a:solidFill>
+                <a:latin typeface="Courier New"/>
+              </a:rPr>
+              <a:t>  --output-dir data/json/ \</a:t>
+            </a:r>
+          </a:p>
+          <a:p>
+            <a:r>
+              <a:rPr sz="1050">
+                <a:solidFill>
+                  <a:srgbClr val="444444"/>
+                </a:solidFill>
+                <a:latin typeface="Courier New"/>
+              </a:rPr>
+              <a:t>  --password   &lt;pw&gt;</a:t>
+            </a:r>
+          </a:p>
+        </p:txBody>
+      </p:sp>
+      <p:sp>
+        <p:nvSpPr>
+          <p:cNvPr id="11" name="TextBox 10"/>
           <p:cNvSpPr txBox="1"/>
           <p:nvPr/>
         </p:nvSpPr>
         <p:spPr>
           <a:xfrm>
-            <a:off x="365760" y="5349240"/>
-            <a:ext cx="11430000" cy="274320"/>
+            <a:off x="6080760" y="1097280"/>
+            <a:ext cx="5760720" cy="274320"/>
           </a:xfrm>
           <a:prstGeom prst="rect">
             <a:avLst/>
@@ -16212,21 +16416,21 @@
                 </a:solidFill>
                 <a:latin typeface="Calibri"/>
               </a:rPr>
-              <a:t>End-to-end workflow:</a:t>
-            </a:r>
-          </a:p>
-        </p:txBody>
-      </p:sp>
-      <p:sp>
-        <p:nvSpPr>
-          <p:cNvPr id="15" name="Rectangle 14"/>
+              <a:t>devices.yaml format</a:t>
+            </a:r>
+          </a:p>
+        </p:txBody>
+      </p:sp>
+      <p:sp>
+        <p:nvSpPr>
+          <p:cNvPr id="12" name="Rectangle 11"/>
           <p:cNvSpPr/>
           <p:nvPr/>
         </p:nvSpPr>
         <p:spPr>
           <a:xfrm>
-            <a:off x="365760" y="5669280"/>
-            <a:ext cx="11430000" cy="960120"/>
+            <a:off x="6080760" y="1417320"/>
+            <a:ext cx="5760720" cy="3383280"/>
           </a:xfrm>
           <a:prstGeom prst="rect">
             <a:avLst/>
@@ -16264,6 +16468,340 @@
       </p:sp>
       <p:sp>
         <p:nvSpPr>
+          <p:cNvPr id="13" name="TextBox 12"/>
+          <p:cNvSpPr txBox="1"/>
+          <p:nvPr/>
+        </p:nvSpPr>
+        <p:spPr>
+          <a:xfrm>
+            <a:off x="6190488" y="1490472"/>
+            <a:ext cx="5541264" cy="3236976"/>
+          </a:xfrm>
+          <a:prstGeom prst="rect">
+            <a:avLst/>
+          </a:prstGeom>
+          <a:noFill/>
+        </p:spPr>
+        <p:txBody>
+          <a:bodyPr wrap="none">
+            <a:spAutoFit/>
+          </a:bodyPr>
+          <a:lstStyle/>
+          <a:p>
+            <a:r>
+              <a:rPr sz="1050">
+                <a:solidFill>
+                  <a:srgbClr val="444444"/>
+                </a:solidFill>
+                <a:latin typeface="Courier New"/>
+              </a:rPr>
+              <a:t>defaults:</a:t>
+            </a:r>
+          </a:p>
+          <a:p>
+            <a:r>
+              <a:rPr sz="1050">
+                <a:solidFill>
+                  <a:srgbClr val="444444"/>
+                </a:solidFill>
+                <a:latin typeface="Courier New"/>
+              </a:rPr>
+              <a:t>  username: admin</a:t>
+            </a:r>
+          </a:p>
+          <a:p>
+            <a:r>
+              <a:rPr sz="1050">
+                <a:solidFill>
+                  <a:srgbClr val="444444"/>
+                </a:solidFill>
+                <a:latin typeface="Courier New"/>
+              </a:rPr>
+              <a:t>  password: ""      # leave blank, use --password</a:t>
+            </a:r>
+          </a:p>
+          <a:p>
+            <a:r>
+              <a:rPr sz="1050">
+                <a:solidFill>
+                  <a:srgbClr val="444444"/>
+                </a:solidFill>
+                <a:latin typeface="Courier New"/>
+              </a:rPr>
+              <a:t>  timeout: 30</a:t>
+            </a:r>
+          </a:p>
+          <a:p>
+            <a:r>
+              <a:rPr sz="1050">
+                <a:solidFill>
+                  <a:srgbClr val="444444"/>
+                </a:solidFill>
+                <a:latin typeface="Courier New"/>
+              </a:rPr>
+              <a:t/>
+            </a:r>
+          </a:p>
+          <a:p>
+            <a:r>
+              <a:rPr sz="1050">
+                <a:solidFill>
+                  <a:srgbClr val="444444"/>
+                </a:solidFill>
+                <a:latin typeface="Courier New"/>
+              </a:rPr>
+              <a:t>devices:</a:t>
+            </a:r>
+          </a:p>
+          <a:p>
+            <a:r>
+              <a:rPr sz="1050">
+                <a:solidFill>
+                  <a:srgbClr val="444444"/>
+                </a:solidFill>
+                <a:latin typeface="Courier New"/>
+              </a:rPr>
+              <a:t>  - hostname: N9K-CAMA-WAN-1</a:t>
+            </a:r>
+          </a:p>
+          <a:p>
+            <a:r>
+              <a:rPr sz="1050">
+                <a:solidFill>
+                  <a:srgbClr val="444444"/>
+                </a:solidFill>
+                <a:latin typeface="Courier New"/>
+              </a:rPr>
+              <a:t>    host: 192.168.1.1</a:t>
+            </a:r>
+          </a:p>
+          <a:p>
+            <a:r>
+              <a:rPr sz="1050">
+                <a:solidFill>
+                  <a:srgbClr val="444444"/>
+                </a:solidFill>
+                <a:latin typeface="Courier New"/>
+              </a:rPr>
+              <a:t>    platform: cisco_nxos</a:t>
+            </a:r>
+          </a:p>
+          <a:p>
+            <a:r>
+              <a:rPr sz="1050">
+                <a:solidFill>
+                  <a:srgbClr val="444444"/>
+                </a:solidFill>
+                <a:latin typeface="Courier New"/>
+              </a:rPr>
+              <a:t/>
+            </a:r>
+          </a:p>
+          <a:p>
+            <a:r>
+              <a:rPr sz="1050">
+                <a:solidFill>
+                  <a:srgbClr val="444444"/>
+                </a:solidFill>
+                <a:latin typeface="Courier New"/>
+              </a:rPr>
+              <a:t>  - hostname: IOS-RTR-1</a:t>
+            </a:r>
+          </a:p>
+          <a:p>
+            <a:r>
+              <a:rPr sz="1050">
+                <a:solidFill>
+                  <a:srgbClr val="444444"/>
+                </a:solidFill>
+                <a:latin typeface="Courier New"/>
+              </a:rPr>
+              <a:t>    host: 10.0.0.1</a:t>
+            </a:r>
+          </a:p>
+          <a:p>
+            <a:r>
+              <a:rPr sz="1050">
+                <a:solidFill>
+                  <a:srgbClr val="444444"/>
+                </a:solidFill>
+                <a:latin typeface="Courier New"/>
+              </a:rPr>
+              <a:t>    platform: cisco_ios</a:t>
+            </a:r>
+          </a:p>
+          <a:p>
+            <a:r>
+              <a:rPr sz="1050">
+                <a:solidFill>
+                  <a:srgbClr val="444444"/>
+                </a:solidFill>
+                <a:latin typeface="Courier New"/>
+              </a:rPr>
+              <a:t>    username: ops        # override defaults</a:t>
+            </a:r>
+          </a:p>
+          <a:p>
+            <a:r>
+              <a:rPr sz="1050">
+                <a:solidFill>
+                  <a:srgbClr val="444444"/>
+                </a:solidFill>
+                <a:latin typeface="Courier New"/>
+              </a:rPr>
+              <a:t/>
+            </a:r>
+          </a:p>
+          <a:p>
+            <a:r>
+              <a:rPr sz="1050">
+                <a:solidFill>
+                  <a:srgbClr val="444444"/>
+                </a:solidFill>
+                <a:latin typeface="Courier New"/>
+              </a:rPr>
+              <a:t>  - hostname: N9K-CAMA-WAN-2</a:t>
+            </a:r>
+          </a:p>
+          <a:p>
+            <a:r>
+              <a:rPr sz="1050">
+                <a:solidFill>
+                  <a:srgbClr val="444444"/>
+                </a:solidFill>
+                <a:latin typeface="Courier New"/>
+              </a:rPr>
+              <a:t>    host: 192.168.1.2</a:t>
+            </a:r>
+          </a:p>
+          <a:p>
+            <a:r>
+              <a:rPr sz="1050">
+                <a:solidFill>
+                  <a:srgbClr val="444444"/>
+                </a:solidFill>
+                <a:latin typeface="Courier New"/>
+              </a:rPr>
+              <a:t>    platform: cisco_nxos</a:t>
+            </a:r>
+          </a:p>
+          <a:p>
+            <a:r>
+              <a:rPr sz="1050">
+                <a:solidFill>
+                  <a:srgbClr val="444444"/>
+                </a:solidFill>
+                <a:latin typeface="Courier New"/>
+              </a:rPr>
+              <a:t>    commands:            # explicit list (overrides registry)</a:t>
+            </a:r>
+          </a:p>
+          <a:p>
+            <a:r>
+              <a:rPr sz="1050">
+                <a:solidFill>
+                  <a:srgbClr val="444444"/>
+                </a:solidFill>
+                <a:latin typeface="Courier New"/>
+              </a:rPr>
+              <a:t>      - show version</a:t>
+            </a:r>
+          </a:p>
+          <a:p>
+            <a:r>
+              <a:rPr sz="1050">
+                <a:solidFill>
+                  <a:srgbClr val="444444"/>
+                </a:solidFill>
+                <a:latin typeface="Courier New"/>
+              </a:rPr>
+              <a:t>      - show ip bgp summary vrf all</a:t>
+            </a:r>
+          </a:p>
+        </p:txBody>
+      </p:sp>
+      <p:sp>
+        <p:nvSpPr>
+          <p:cNvPr id="14" name="TextBox 13"/>
+          <p:cNvSpPr txBox="1"/>
+          <p:nvPr/>
+        </p:nvSpPr>
+        <p:spPr>
+          <a:xfrm>
+            <a:off x="365760" y="5349240"/>
+            <a:ext cx="11430000" cy="274320"/>
+          </a:xfrm>
+          <a:prstGeom prst="rect">
+            <a:avLst/>
+          </a:prstGeom>
+          <a:noFill/>
+        </p:spPr>
+        <p:txBody>
+          <a:bodyPr wrap="square">
+            <a:spAutoFit/>
+          </a:bodyPr>
+          <a:lstStyle/>
+          <a:p>
+            <a:pPr algn="l"/>
+            <a:r>
+              <a:rPr sz="1300" b="1" i="0">
+                <a:solidFill>
+                  <a:srgbClr val="1A355E"/>
+                </a:solidFill>
+                <a:latin typeface="Calibri"/>
+              </a:rPr>
+              <a:t>End-to-end workflow:</a:t>
+            </a:r>
+          </a:p>
+        </p:txBody>
+      </p:sp>
+      <p:sp>
+        <p:nvSpPr>
+          <p:cNvPr id="15" name="Rectangle 14"/>
+          <p:cNvSpPr/>
+          <p:nvPr/>
+        </p:nvSpPr>
+        <p:spPr>
+          <a:xfrm>
+            <a:off x="365760" y="5669280"/>
+            <a:ext cx="11430000" cy="960120"/>
+          </a:xfrm>
+          <a:prstGeom prst="rect">
+            <a:avLst/>
+          </a:prstGeom>
+          <a:solidFill>
+            <a:srgbClr val="EEF2F7"/>
+          </a:solidFill>
+          <a:ln w="6350">
+            <a:solidFill>
+              <a:srgbClr val="CCCCCC"/>
+            </a:solidFill>
+          </a:ln>
+        </p:spPr>
+        <p:style>
+          <a:lnRef idx="1">
+            <a:schemeClr val="accent1"/>
+          </a:lnRef>
+          <a:fillRef idx="3">
+            <a:schemeClr val="accent1"/>
+          </a:fillRef>
+          <a:effectRef idx="2">
+            <a:schemeClr val="accent1"/>
+          </a:effectRef>
+          <a:fontRef idx="minor">
+            <a:schemeClr val="lt1"/>
+          </a:fontRef>
+        </p:style>
+        <p:txBody>
+          <a:bodyPr rtlCol="0" anchor="ctr"/>
+          <a:lstStyle/>
+          <a:p>
+            <a:pPr algn="ctr"/>
+          </a:p>
+        </p:txBody>
+      </p:sp>
+      <p:sp>
+        <p:nvSpPr>
           <p:cNvPr id="16" name="TextBox 15"/>
           <p:cNvSpPr txBox="1"/>
           <p:nvPr/>
@@ -16359,7 +16897,7 @@
 </p:sld>
 </file>
 
-<file path=ppt/slides/slide24.xml><?xml version="1.0" encoding="utf-8"?>
+<file path=ppt/slides/slide25.xml><?xml version="1.0" encoding="utf-8"?>
 <p:sld xmlns:a="http://schemas.openxmlformats.org/drawingml/2006/main" xmlns:p="http://schemas.openxmlformats.org/presentationml/2006/main" xmlns:r="http://schemas.openxmlformats.org/officeDocument/2006/relationships">
   <p:cSld>
     <p:spTree>

</xml_diff>